<commit_message>
tweaking spacing in template
</commit_message>
<xml_diff>
--- a/docs/presentations/common/branding/ncar/template.pptx
+++ b/docs/presentations/common/branding/ncar/template.pptx
@@ -588,8 +588,8 @@
         </p:blipFill>
         <p:spPr>
           <a:xfrm>
-            <a:off x="685917" y="788501"/>
-            <a:ext cx="4572000" cy="1193133"/>
+            <a:off x="383095" y="655501"/>
+            <a:ext cx="5497115" cy="1434556"/>
           </a:xfrm>
           <a:prstGeom prst="rect">
             <a:avLst/>
@@ -795,8 +795,8 @@
         </p:nvSpPr>
         <p:spPr>
           <a:xfrm>
-            <a:off x="691024" y="6090236"/>
-            <a:ext cx="4483141" cy="366319"/>
+            <a:off x="691024" y="6199095"/>
+            <a:ext cx="4483141" cy="648022"/>
           </a:xfrm>
           <a:prstGeom prst="rect">
             <a:avLst/>
@@ -824,7 +824,9 @@
             <a:r>
               <a:rPr lang="en-US" sz="800" i="1" baseline="0" dirty="0">
                 <a:solidFill>
-                  <a:schemeClr val="dk1"/>
+                  <a:schemeClr val="bg1">
+                    <a:lumMod val="50000"/>
+                  </a:schemeClr>
                 </a:solidFill>
                 <a:latin typeface="+mn-lt"/>
                 <a:ea typeface="Poppins"/>
@@ -846,7 +848,9 @@
             </a:pPr>
             <a:endParaRPr lang="en-US" sz="800" i="1" baseline="0" dirty="0">
               <a:solidFill>
-                <a:schemeClr val="dk1"/>
+                <a:schemeClr val="bg1">
+                  <a:lumMod val="50000"/>
+                </a:schemeClr>
               </a:solidFill>
               <a:latin typeface="+mn-lt"/>
               <a:ea typeface="Poppins"/>
@@ -909,7 +913,7 @@
         <p:spPr>
           <a:xfrm>
             <a:off x="691024" y="2955073"/>
-            <a:ext cx="4828830" cy="1683309"/>
+            <a:ext cx="5509478" cy="1683309"/>
           </a:xfrm>
           <a:noFill/>
         </p:spPr>
@@ -947,7 +951,7 @@
         <p:spPr>
           <a:xfrm>
             <a:off x="691024" y="4778477"/>
-            <a:ext cx="4828830" cy="752519"/>
+            <a:ext cx="5509478" cy="1291021"/>
           </a:xfrm>
           <a:prstGeom prst="rect">
             <a:avLst/>
@@ -958,7 +962,7 @@
           <a:lstStyle>
             <a:lvl1pPr marL="0" indent="0" algn="l">
               <a:buNone/>
-              <a:defRPr sz="2400" baseline="0">
+              <a:defRPr sz="1800" baseline="0">
                 <a:solidFill>
                   <a:schemeClr val="tx1"/>
                 </a:solidFill>
@@ -1092,10 +1096,10 @@
       </p:sp>
       <p:sp>
         <p:nvSpPr>
-          <p:cNvPr id="5" name="Date Placeholder 4">
+          <p:cNvPr id="5" name="Slide Number Placeholder 5">
             <a:extLst>
               <a:ext uri="{FF2B5EF4-FFF2-40B4-BE49-F238E27FC236}">
-                <a16:creationId xmlns:a16="http://schemas.microsoft.com/office/drawing/2014/main" id="{4666DEF4-AE3F-B67E-D929-B38E9DE1EBA3}"/>
+                <a16:creationId xmlns:a16="http://schemas.microsoft.com/office/drawing/2014/main" id="{34A6C262-CDA0-EDB1-2AC2-FFCD3EDF5E91}"/>
               </a:ext>
             </a:extLst>
           </p:cNvPr>
@@ -1103,67 +1107,29 @@
             <a:spLocks noGrp="1"/>
           </p:cNvSpPr>
           <p:nvPr>
-            <p:ph type="dt" sz="half" idx="10"/>
+            <p:ph type="sldNum" sz="quarter" idx="4"/>
           </p:nvPr>
         </p:nvSpPr>
-        <p:spPr/>
-        <p:txBody>
-          <a:bodyPr/>
-          <a:lstStyle/>
-          <a:p>
-            <a:fld id="{34459720-2A4C-D342-9515-00AC0588A96C}" type="datetimeFigureOut">
-              <a:rPr lang="en-US" smtClean="0"/>
-              <a:t>4/22/26</a:t>
-            </a:fld>
-            <a:endParaRPr lang="en-US"/>
-          </a:p>
-        </p:txBody>
-      </p:sp>
-      <p:sp>
-        <p:nvSpPr>
-          <p:cNvPr id="10" name="Footer Placeholder 9">
-            <a:extLst>
-              <a:ext uri="{FF2B5EF4-FFF2-40B4-BE49-F238E27FC236}">
-                <a16:creationId xmlns:a16="http://schemas.microsoft.com/office/drawing/2014/main" id="{869E98FA-BD26-87E8-E369-4C0D2678D039}"/>
-              </a:ext>
-            </a:extLst>
-          </p:cNvPr>
-          <p:cNvSpPr>
-            <a:spLocks noGrp="1"/>
-          </p:cNvSpPr>
-          <p:nvPr>
-            <p:ph type="ftr" sz="quarter" idx="11"/>
-          </p:nvPr>
-        </p:nvSpPr>
-        <p:spPr/>
-        <p:txBody>
-          <a:bodyPr/>
-          <a:lstStyle/>
-          <a:p>
-            <a:endParaRPr lang="en-US"/>
-          </a:p>
-        </p:txBody>
-      </p:sp>
-      <p:sp>
-        <p:nvSpPr>
-          <p:cNvPr id="13" name="Slide Number Placeholder 12">
-            <a:extLst>
-              <a:ext uri="{FF2B5EF4-FFF2-40B4-BE49-F238E27FC236}">
-                <a16:creationId xmlns:a16="http://schemas.microsoft.com/office/drawing/2014/main" id="{569DBCF1-84BE-A39E-3D30-1198C500AB4F}"/>
-              </a:ext>
-            </a:extLst>
-          </p:cNvPr>
-          <p:cNvSpPr>
-            <a:spLocks noGrp="1"/>
-          </p:cNvSpPr>
-          <p:nvPr>
-            <p:ph type="sldNum" sz="quarter" idx="12"/>
-          </p:nvPr>
-        </p:nvSpPr>
-        <p:spPr/>
-        <p:txBody>
-          <a:bodyPr/>
-          <a:lstStyle/>
+        <p:spPr>
+          <a:xfrm>
+            <a:off x="13014" y="6481724"/>
+            <a:ext cx="477640" cy="365125"/>
+          </a:xfrm>
+          <a:prstGeom prst="rect">
+            <a:avLst/>
+          </a:prstGeom>
+        </p:spPr>
+        <p:txBody>
+          <a:bodyPr vert="horz" lIns="91440" tIns="45720" rIns="91440" bIns="45720" rtlCol="0" anchor="ctr"/>
+          <a:lstStyle>
+            <a:lvl1pPr algn="ctr">
+              <a:defRPr sz="1200" baseline="0">
+                <a:solidFill>
+                  <a:schemeClr val="tx1"/>
+                </a:solidFill>
+              </a:defRPr>
+            </a:lvl1pPr>
+          </a:lstStyle>
           <a:p>
             <a:fld id="{C5EF2332-01BF-834F-8236-50238282D533}" type="slidenum">
               <a:rPr lang="en-US" smtClean="0"/>
@@ -1175,6 +1141,95 @@
                 <a:schemeClr val="tx1"/>
               </a:solidFill>
             </a:endParaRPr>
+          </a:p>
+        </p:txBody>
+      </p:sp>
+      <p:sp>
+        <p:nvSpPr>
+          <p:cNvPr id="10" name="Date Placeholder 4">
+            <a:extLst>
+              <a:ext uri="{FF2B5EF4-FFF2-40B4-BE49-F238E27FC236}">
+                <a16:creationId xmlns:a16="http://schemas.microsoft.com/office/drawing/2014/main" id="{2B6AD2BA-BE48-2071-356C-379C4FE4F044}"/>
+              </a:ext>
+            </a:extLst>
+          </p:cNvPr>
+          <p:cNvSpPr>
+            <a:spLocks noGrp="1"/>
+          </p:cNvSpPr>
+          <p:nvPr>
+            <p:ph type="dt" sz="half" idx="2"/>
+          </p:nvPr>
+        </p:nvSpPr>
+        <p:spPr>
+          <a:xfrm>
+            <a:off x="10436086" y="6556499"/>
+            <a:ext cx="1374913" cy="182799"/>
+          </a:xfrm>
+          <a:prstGeom prst="rect">
+            <a:avLst/>
+          </a:prstGeom>
+        </p:spPr>
+        <p:txBody>
+          <a:bodyPr vert="horz" lIns="91440" tIns="45720" rIns="91440" bIns="45720" rtlCol="0" anchor="ctr"/>
+          <a:lstStyle>
+            <a:lvl1pPr algn="r">
+              <a:defRPr sz="1200" baseline="0">
+                <a:solidFill>
+                  <a:schemeClr val="tx1"/>
+                </a:solidFill>
+              </a:defRPr>
+            </a:lvl1pPr>
+          </a:lstStyle>
+          <a:p>
+            <a:pPr algn="r"/>
+            <a:fld id="{34459720-2A4C-D342-9515-00AC0588A96C}" type="datetimeFigureOut">
+              <a:rPr lang="en-US" smtClean="0"/>
+              <a:pPr/>
+              <a:t>4/22/26</a:t>
+            </a:fld>
+            <a:endParaRPr lang="en-US" dirty="0"/>
+          </a:p>
+        </p:txBody>
+      </p:sp>
+      <p:sp>
+        <p:nvSpPr>
+          <p:cNvPr id="13" name="Footer Placeholder 6">
+            <a:extLst>
+              <a:ext uri="{FF2B5EF4-FFF2-40B4-BE49-F238E27FC236}">
+                <a16:creationId xmlns:a16="http://schemas.microsoft.com/office/drawing/2014/main" id="{11B4CD95-6513-D8A0-9F1F-34F66817456E}"/>
+              </a:ext>
+            </a:extLst>
+          </p:cNvPr>
+          <p:cNvSpPr>
+            <a:spLocks noGrp="1"/>
+          </p:cNvSpPr>
+          <p:nvPr>
+            <p:ph type="ftr" sz="quarter" idx="3"/>
+          </p:nvPr>
+        </p:nvSpPr>
+        <p:spPr>
+          <a:xfrm>
+            <a:off x="555265" y="6556499"/>
+            <a:ext cx="4114800" cy="182799"/>
+          </a:xfrm>
+          <a:prstGeom prst="rect">
+            <a:avLst/>
+          </a:prstGeom>
+        </p:spPr>
+        <p:txBody>
+          <a:bodyPr vert="horz" lIns="91440" tIns="45720" rIns="91440" bIns="45720" rtlCol="0" anchor="ctr"/>
+          <a:lstStyle>
+            <a:lvl1pPr algn="l">
+              <a:defRPr sz="1200" baseline="0">
+                <a:solidFill>
+                  <a:schemeClr val="tx1"/>
+                </a:solidFill>
+              </a:defRPr>
+            </a:lvl1pPr>
+          </a:lstStyle>
+          <a:p>
+            <a:pPr algn="l"/>
+            <a:endParaRPr lang="en-US" dirty="0"/>
           </a:p>
         </p:txBody>
       </p:sp>
@@ -1207,7 +1262,2057 @@
 </p:sldLayout>
 </file>
 
-<file path=ppt/slideLayouts/slideLayout10.xml><?xml version="1.0" encoding="utf-8"?>
+<file path=ppt/slideLayouts/slideLayout2.xml><?xml version="1.0" encoding="utf-8"?>
+<p:sldLayout xmlns:a="http://schemas.openxmlformats.org/drawingml/2006/main" xmlns:r="http://schemas.openxmlformats.org/officeDocument/2006/relationships" xmlns:p="http://schemas.openxmlformats.org/presentationml/2006/main" type="titleOnly" preserve="1">
+  <p:cSld name="Title Only">
+    <p:spTree>
+      <p:nvGrpSpPr>
+        <p:cNvPr id="1" name=""/>
+        <p:cNvGrpSpPr/>
+        <p:nvPr/>
+      </p:nvGrpSpPr>
+      <p:grpSpPr>
+        <a:xfrm>
+          <a:off x="0" y="0"/>
+          <a:ext cx="0" cy="0"/>
+          <a:chOff x="0" y="0"/>
+          <a:chExt cx="0" cy="0"/>
+        </a:xfrm>
+      </p:grpSpPr>
+      <p:sp>
+        <p:nvSpPr>
+          <p:cNvPr id="2" name="Title 1"/>
+          <p:cNvSpPr>
+            <a:spLocks noGrp="1"/>
+          </p:cNvSpPr>
+          <p:nvPr>
+            <p:ph type="title"/>
+          </p:nvPr>
+        </p:nvSpPr>
+        <p:spPr>
+          <a:xfrm>
+            <a:off x="381000" y="0"/>
+            <a:ext cx="9906000" cy="457200"/>
+          </a:xfrm>
+          <a:prstGeom prst="rect">
+            <a:avLst/>
+          </a:prstGeom>
+        </p:spPr>
+        <p:txBody>
+          <a:bodyPr/>
+          <a:lstStyle/>
+          <a:p>
+            <a:r>
+              <a:rPr lang="en-US"/>
+              <a:t>Click to edit Master title style</a:t>
+            </a:r>
+          </a:p>
+        </p:txBody>
+      </p:sp>
+      <p:sp>
+        <p:nvSpPr>
+          <p:cNvPr id="3" name="Slide Number Placeholder 5">
+            <a:extLst>
+              <a:ext uri="{FF2B5EF4-FFF2-40B4-BE49-F238E27FC236}">
+                <a16:creationId xmlns:a16="http://schemas.microsoft.com/office/drawing/2014/main" id="{DE55E6F4-F503-8139-B06C-594972EDCC66}"/>
+              </a:ext>
+            </a:extLst>
+          </p:cNvPr>
+          <p:cNvSpPr txBox="1">
+            <a:spLocks/>
+          </p:cNvSpPr>
+          <p:nvPr userDrawn="1"/>
+        </p:nvSpPr>
+        <p:spPr>
+          <a:xfrm>
+            <a:off x="13014" y="6481724"/>
+            <a:ext cx="477640" cy="365125"/>
+          </a:xfrm>
+          <a:prstGeom prst="rect">
+            <a:avLst/>
+          </a:prstGeom>
+        </p:spPr>
+        <p:txBody>
+          <a:bodyPr vert="horz" lIns="91440" tIns="45720" rIns="91440" bIns="45720" rtlCol="0" anchor="ctr"/>
+          <a:lstStyle>
+            <a:defPPr>
+              <a:defRPr lang="en-US"/>
+            </a:defPPr>
+            <a:lvl1pPr marL="0" algn="ctr" defTabSz="609585" rtl="0" eaLnBrk="1" latinLnBrk="0" hangingPunct="1">
+              <a:defRPr sz="1200" kern="1200" baseline="0">
+                <a:solidFill>
+                  <a:schemeClr val="tx1"/>
+                </a:solidFill>
+                <a:latin typeface="+mn-lt"/>
+                <a:ea typeface="+mn-ea"/>
+                <a:cs typeface="+mn-cs"/>
+              </a:defRPr>
+            </a:lvl1pPr>
+            <a:lvl2pPr marL="609585" algn="l" defTabSz="609585" rtl="0" eaLnBrk="1" latinLnBrk="0" hangingPunct="1">
+              <a:defRPr sz="2400" kern="1200">
+                <a:solidFill>
+                  <a:schemeClr val="tx1"/>
+                </a:solidFill>
+                <a:latin typeface="+mn-lt"/>
+                <a:ea typeface="+mn-ea"/>
+                <a:cs typeface="+mn-cs"/>
+              </a:defRPr>
+            </a:lvl2pPr>
+            <a:lvl3pPr marL="1219170" algn="l" defTabSz="609585" rtl="0" eaLnBrk="1" latinLnBrk="0" hangingPunct="1">
+              <a:defRPr sz="2400" kern="1200">
+                <a:solidFill>
+                  <a:schemeClr val="tx1"/>
+                </a:solidFill>
+                <a:latin typeface="+mn-lt"/>
+                <a:ea typeface="+mn-ea"/>
+                <a:cs typeface="+mn-cs"/>
+              </a:defRPr>
+            </a:lvl3pPr>
+            <a:lvl4pPr marL="1828754" algn="l" defTabSz="609585" rtl="0" eaLnBrk="1" latinLnBrk="0" hangingPunct="1">
+              <a:defRPr sz="2400" kern="1200">
+                <a:solidFill>
+                  <a:schemeClr val="tx1"/>
+                </a:solidFill>
+                <a:latin typeface="+mn-lt"/>
+                <a:ea typeface="+mn-ea"/>
+                <a:cs typeface="+mn-cs"/>
+              </a:defRPr>
+            </a:lvl4pPr>
+            <a:lvl5pPr marL="2438339" algn="l" defTabSz="609585" rtl="0" eaLnBrk="1" latinLnBrk="0" hangingPunct="1">
+              <a:defRPr sz="2400" kern="1200">
+                <a:solidFill>
+                  <a:schemeClr val="tx1"/>
+                </a:solidFill>
+                <a:latin typeface="+mn-lt"/>
+                <a:ea typeface="+mn-ea"/>
+                <a:cs typeface="+mn-cs"/>
+              </a:defRPr>
+            </a:lvl5pPr>
+            <a:lvl6pPr marL="3047924" algn="l" defTabSz="609585" rtl="0" eaLnBrk="1" latinLnBrk="0" hangingPunct="1">
+              <a:defRPr sz="2400" kern="1200">
+                <a:solidFill>
+                  <a:schemeClr val="tx1"/>
+                </a:solidFill>
+                <a:latin typeface="+mn-lt"/>
+                <a:ea typeface="+mn-ea"/>
+                <a:cs typeface="+mn-cs"/>
+              </a:defRPr>
+            </a:lvl6pPr>
+            <a:lvl7pPr marL="3657509" algn="l" defTabSz="609585" rtl="0" eaLnBrk="1" latinLnBrk="0" hangingPunct="1">
+              <a:defRPr sz="2400" kern="1200">
+                <a:solidFill>
+                  <a:schemeClr val="tx1"/>
+                </a:solidFill>
+                <a:latin typeface="+mn-lt"/>
+                <a:ea typeface="+mn-ea"/>
+                <a:cs typeface="+mn-cs"/>
+              </a:defRPr>
+            </a:lvl7pPr>
+            <a:lvl8pPr marL="4267093" algn="l" defTabSz="609585" rtl="0" eaLnBrk="1" latinLnBrk="0" hangingPunct="1">
+              <a:defRPr sz="2400" kern="1200">
+                <a:solidFill>
+                  <a:schemeClr val="tx1"/>
+                </a:solidFill>
+                <a:latin typeface="+mn-lt"/>
+                <a:ea typeface="+mn-ea"/>
+                <a:cs typeface="+mn-cs"/>
+              </a:defRPr>
+            </a:lvl8pPr>
+            <a:lvl9pPr marL="4876678" algn="l" defTabSz="609585" rtl="0" eaLnBrk="1" latinLnBrk="0" hangingPunct="1">
+              <a:defRPr sz="2400" kern="1200">
+                <a:solidFill>
+                  <a:schemeClr val="tx1"/>
+                </a:solidFill>
+                <a:latin typeface="+mn-lt"/>
+                <a:ea typeface="+mn-ea"/>
+                <a:cs typeface="+mn-cs"/>
+              </a:defRPr>
+            </a:lvl9pPr>
+          </a:lstStyle>
+          <a:p>
+            <a:fld id="{C5EF2332-01BF-834F-8236-50238282D533}" type="slidenum">
+              <a:rPr lang="en-US" smtClean="0"/>
+              <a:pPr/>
+              <a:t>‹#›</a:t>
+            </a:fld>
+            <a:endParaRPr lang="en-US" dirty="0"/>
+          </a:p>
+        </p:txBody>
+      </p:sp>
+    </p:spTree>
+    <p:extLst>
+      <p:ext uri="{BB962C8B-B14F-4D97-AF65-F5344CB8AC3E}">
+        <p14:creationId xmlns:p14="http://schemas.microsoft.com/office/powerpoint/2010/main" val="3472721253"/>
+      </p:ext>
+    </p:extLst>
+  </p:cSld>
+  <p:clrMapOvr>
+    <a:masterClrMapping/>
+  </p:clrMapOvr>
+</p:sldLayout>
+</file>
+
+<file path=ppt/slideLayouts/slideLayout3.xml><?xml version="1.0" encoding="utf-8"?>
+<p:sldLayout xmlns:a="http://schemas.openxmlformats.org/drawingml/2006/main" xmlns:r="http://schemas.openxmlformats.org/officeDocument/2006/relationships" xmlns:p="http://schemas.openxmlformats.org/presentationml/2006/main" preserve="1" userDrawn="1">
+  <p:cSld name="Blank">
+    <p:spTree>
+      <p:nvGrpSpPr>
+        <p:cNvPr id="1" name=""/>
+        <p:cNvGrpSpPr/>
+        <p:nvPr/>
+      </p:nvGrpSpPr>
+      <p:grpSpPr>
+        <a:xfrm>
+          <a:off x="0" y="0"/>
+          <a:ext cx="0" cy="0"/>
+          <a:chOff x="0" y="0"/>
+          <a:chExt cx="0" cy="0"/>
+        </a:xfrm>
+      </p:grpSpPr>
+      <p:sp>
+        <p:nvSpPr>
+          <p:cNvPr id="2" name="Title 1">
+            <a:extLst>
+              <a:ext uri="{FF2B5EF4-FFF2-40B4-BE49-F238E27FC236}">
+                <a16:creationId xmlns:a16="http://schemas.microsoft.com/office/drawing/2014/main" id="{C6B8646D-489E-60FE-7A18-9CDC45D41807}"/>
+              </a:ext>
+            </a:extLst>
+          </p:cNvPr>
+          <p:cNvSpPr>
+            <a:spLocks noGrp="1"/>
+          </p:cNvSpPr>
+          <p:nvPr>
+            <p:ph type="title"/>
+          </p:nvPr>
+        </p:nvSpPr>
+        <p:spPr/>
+        <p:txBody>
+          <a:bodyPr/>
+          <a:lstStyle/>
+          <a:p>
+            <a:r>
+              <a:rPr lang="en-US"/>
+              <a:t>Click to edit Master title style</a:t>
+            </a:r>
+          </a:p>
+        </p:txBody>
+      </p:sp>
+      <p:sp>
+        <p:nvSpPr>
+          <p:cNvPr id="3" name="Slide Number Placeholder 2">
+            <a:extLst>
+              <a:ext uri="{FF2B5EF4-FFF2-40B4-BE49-F238E27FC236}">
+                <a16:creationId xmlns:a16="http://schemas.microsoft.com/office/drawing/2014/main" id="{64458514-F400-26C7-7288-45B54DD965FB}"/>
+              </a:ext>
+            </a:extLst>
+          </p:cNvPr>
+          <p:cNvSpPr>
+            <a:spLocks noGrp="1"/>
+          </p:cNvSpPr>
+          <p:nvPr>
+            <p:ph type="sldNum" sz="quarter" idx="10"/>
+          </p:nvPr>
+        </p:nvSpPr>
+        <p:spPr/>
+        <p:txBody>
+          <a:bodyPr/>
+          <a:lstStyle/>
+          <a:p>
+            <a:fld id="{C5EF2332-01BF-834F-8236-50238282D533}" type="slidenum">
+              <a:rPr lang="en-US" smtClean="0"/>
+              <a:pPr/>
+              <a:t>‹#›</a:t>
+            </a:fld>
+            <a:endParaRPr lang="en-US" dirty="0">
+              <a:solidFill>
+                <a:schemeClr val="tx1"/>
+              </a:solidFill>
+            </a:endParaRPr>
+          </a:p>
+        </p:txBody>
+      </p:sp>
+      <p:sp>
+        <p:nvSpPr>
+          <p:cNvPr id="4" name="Date Placeholder 3">
+            <a:extLst>
+              <a:ext uri="{FF2B5EF4-FFF2-40B4-BE49-F238E27FC236}">
+                <a16:creationId xmlns:a16="http://schemas.microsoft.com/office/drawing/2014/main" id="{909AA338-C5F6-2612-8A95-BBE47D6054A0}"/>
+              </a:ext>
+            </a:extLst>
+          </p:cNvPr>
+          <p:cNvSpPr>
+            <a:spLocks noGrp="1"/>
+          </p:cNvSpPr>
+          <p:nvPr>
+            <p:ph type="dt" sz="half" idx="11"/>
+          </p:nvPr>
+        </p:nvSpPr>
+        <p:spPr/>
+        <p:txBody>
+          <a:bodyPr/>
+          <a:lstStyle/>
+          <a:p>
+            <a:fld id="{34459720-2A4C-D342-9515-00AC0588A96C}" type="datetimeFigureOut">
+              <a:rPr lang="en-US" smtClean="0"/>
+              <a:t>4/22/26</a:t>
+            </a:fld>
+            <a:endParaRPr lang="en-US"/>
+          </a:p>
+        </p:txBody>
+      </p:sp>
+      <p:sp>
+        <p:nvSpPr>
+          <p:cNvPr id="5" name="Footer Placeholder 4">
+            <a:extLst>
+              <a:ext uri="{FF2B5EF4-FFF2-40B4-BE49-F238E27FC236}">
+                <a16:creationId xmlns:a16="http://schemas.microsoft.com/office/drawing/2014/main" id="{7911FF1B-B65F-DC84-C2A5-47B7C47CA3BD}"/>
+              </a:ext>
+            </a:extLst>
+          </p:cNvPr>
+          <p:cNvSpPr>
+            <a:spLocks noGrp="1"/>
+          </p:cNvSpPr>
+          <p:nvPr>
+            <p:ph type="ftr" sz="quarter" idx="12"/>
+          </p:nvPr>
+        </p:nvSpPr>
+        <p:spPr>
+          <a:xfrm>
+            <a:off x="555265" y="6556499"/>
+            <a:ext cx="4114800" cy="182799"/>
+          </a:xfrm>
+          <a:prstGeom prst="rect">
+            <a:avLst/>
+          </a:prstGeom>
+        </p:spPr>
+        <p:txBody>
+          <a:bodyPr/>
+          <a:lstStyle/>
+          <a:p>
+            <a:endParaRPr lang="en-US"/>
+          </a:p>
+        </p:txBody>
+      </p:sp>
+    </p:spTree>
+    <p:extLst>
+      <p:ext uri="{BB962C8B-B14F-4D97-AF65-F5344CB8AC3E}">
+        <p14:creationId xmlns:p14="http://schemas.microsoft.com/office/powerpoint/2010/main" val="2456570876"/>
+      </p:ext>
+    </p:extLst>
+  </p:cSld>
+  <p:clrMapOvr>
+    <a:masterClrMapping/>
+  </p:clrMapOvr>
+</p:sldLayout>
+</file>
+
+<file path=ppt/slideLayouts/slideLayout4.xml><?xml version="1.0" encoding="utf-8"?>
+<p:sldLayout xmlns:a="http://schemas.openxmlformats.org/drawingml/2006/main" xmlns:r="http://schemas.openxmlformats.org/officeDocument/2006/relationships" xmlns:p="http://schemas.openxmlformats.org/presentationml/2006/main" preserve="1" userDrawn="1">
+  <p:cSld name="Title and Content">
+    <p:spTree>
+      <p:nvGrpSpPr>
+        <p:cNvPr id="1" name=""/>
+        <p:cNvGrpSpPr/>
+        <p:nvPr/>
+      </p:nvGrpSpPr>
+      <p:grpSpPr>
+        <a:xfrm>
+          <a:off x="0" y="0"/>
+          <a:ext cx="0" cy="0"/>
+          <a:chOff x="0" y="0"/>
+          <a:chExt cx="0" cy="0"/>
+        </a:xfrm>
+      </p:grpSpPr>
+      <p:sp>
+        <p:nvSpPr>
+          <p:cNvPr id="3" name="Content Placeholder 2"/>
+          <p:cNvSpPr>
+            <a:spLocks noGrp="1"/>
+          </p:cNvSpPr>
+          <p:nvPr>
+            <p:ph idx="1"/>
+          </p:nvPr>
+        </p:nvSpPr>
+        <p:spPr>
+          <a:xfrm>
+            <a:off x="384048" y="786384"/>
+            <a:ext cx="11430000" cy="5486400"/>
+          </a:xfrm>
+          <a:prstGeom prst="rect">
+            <a:avLst/>
+          </a:prstGeom>
+        </p:spPr>
+        <p:txBody>
+          <a:bodyPr/>
+          <a:lstStyle>
+            <a:lvl1pPr marL="228600" indent="-228600">
+              <a:buClrTx/>
+              <a:buFontTx/>
+              <a:buNone/>
+              <a:defRPr baseline="0">
+                <a:latin typeface="Poppins" pitchFamily="2" charset="77"/>
+              </a:defRPr>
+            </a:lvl1pPr>
+            <a:lvl2pPr marL="457200" indent="-228600">
+              <a:buFont typeface="Arial" panose="020B0604020202020204" pitchFamily="34" charset="0"/>
+              <a:buChar char="•"/>
+              <a:defRPr baseline="0"/>
+            </a:lvl2pPr>
+            <a:lvl3pPr marL="914400" indent="-228600">
+              <a:buFont typeface="Wingdings" pitchFamily="2" charset="2"/>
+              <a:buChar char="§"/>
+              <a:defRPr baseline="0"/>
+            </a:lvl3pPr>
+            <a:lvl4pPr marL="1371600" indent="-228600">
+              <a:defRPr baseline="0"/>
+            </a:lvl4pPr>
+            <a:lvl5pPr marL="1828800" indent="-228600">
+              <a:defRPr baseline="0"/>
+            </a:lvl5pPr>
+          </a:lstStyle>
+          <a:p>
+            <a:pPr lvl="0"/>
+            <a:endParaRPr lang="en-US" dirty="0"/>
+          </a:p>
+          <a:p>
+            <a:pPr lvl="0"/>
+            <a:r>
+              <a:rPr lang="en-US" dirty="0"/>
+              <a:t>Click to edit Master text styles</a:t>
+            </a:r>
+          </a:p>
+          <a:p>
+            <a:pPr lvl="1"/>
+            <a:r>
+              <a:rPr lang="en-US" dirty="0"/>
+              <a:t>Second level</a:t>
+            </a:r>
+          </a:p>
+          <a:p>
+            <a:pPr lvl="2"/>
+            <a:r>
+              <a:rPr lang="en-US" dirty="0"/>
+              <a:t>Third level</a:t>
+            </a:r>
+          </a:p>
+          <a:p>
+            <a:pPr lvl="3"/>
+            <a:r>
+              <a:rPr lang="en-US" dirty="0"/>
+              <a:t>Fourth level</a:t>
+            </a:r>
+          </a:p>
+          <a:p>
+            <a:pPr lvl="4"/>
+            <a:r>
+              <a:rPr lang="en-US" dirty="0"/>
+              <a:t>Fifth level</a:t>
+            </a:r>
+          </a:p>
+        </p:txBody>
+      </p:sp>
+      <p:sp>
+        <p:nvSpPr>
+          <p:cNvPr id="10" name="Title 8">
+            <a:extLst>
+              <a:ext uri="{FF2B5EF4-FFF2-40B4-BE49-F238E27FC236}">
+                <a16:creationId xmlns:a16="http://schemas.microsoft.com/office/drawing/2014/main" id="{16C1CE93-3040-4E7C-AF01-3DC2EF8F8C7E}"/>
+              </a:ext>
+            </a:extLst>
+          </p:cNvPr>
+          <p:cNvSpPr>
+            <a:spLocks noGrp="1"/>
+          </p:cNvSpPr>
+          <p:nvPr>
+            <p:ph type="title"/>
+          </p:nvPr>
+        </p:nvSpPr>
+        <p:spPr>
+          <a:xfrm>
+            <a:off x="381000" y="0"/>
+            <a:ext cx="9905999" cy="457200"/>
+          </a:xfrm>
+        </p:spPr>
+        <p:txBody>
+          <a:bodyPr/>
+          <a:lstStyle/>
+          <a:p>
+            <a:r>
+              <a:rPr lang="en-US" dirty="0"/>
+              <a:t>Click to edit Master title style</a:t>
+            </a:r>
+          </a:p>
+        </p:txBody>
+      </p:sp>
+      <p:sp>
+        <p:nvSpPr>
+          <p:cNvPr id="11" name="Slide Number Placeholder 5">
+            <a:extLst>
+              <a:ext uri="{FF2B5EF4-FFF2-40B4-BE49-F238E27FC236}">
+                <a16:creationId xmlns:a16="http://schemas.microsoft.com/office/drawing/2014/main" id="{6AFDE7CA-02E9-BF8D-B70C-37475DB92919}"/>
+              </a:ext>
+            </a:extLst>
+          </p:cNvPr>
+          <p:cNvSpPr>
+            <a:spLocks noGrp="1"/>
+          </p:cNvSpPr>
+          <p:nvPr>
+            <p:ph type="sldNum" sz="quarter" idx="4"/>
+          </p:nvPr>
+        </p:nvSpPr>
+        <p:spPr>
+          <a:xfrm>
+            <a:off x="13014" y="6481724"/>
+            <a:ext cx="477640" cy="365125"/>
+          </a:xfrm>
+          <a:prstGeom prst="rect">
+            <a:avLst/>
+          </a:prstGeom>
+        </p:spPr>
+        <p:txBody>
+          <a:bodyPr vert="horz" lIns="91440" tIns="45720" rIns="91440" bIns="45720" rtlCol="0" anchor="ctr"/>
+          <a:lstStyle>
+            <a:lvl1pPr algn="ctr">
+              <a:defRPr sz="1200" baseline="0">
+                <a:solidFill>
+                  <a:schemeClr val="tx1"/>
+                </a:solidFill>
+              </a:defRPr>
+            </a:lvl1pPr>
+          </a:lstStyle>
+          <a:p>
+            <a:fld id="{C5EF2332-01BF-834F-8236-50238282D533}" type="slidenum">
+              <a:rPr lang="en-US" smtClean="0"/>
+              <a:pPr/>
+              <a:t>‹#›</a:t>
+            </a:fld>
+            <a:endParaRPr lang="en-US" dirty="0">
+              <a:solidFill>
+                <a:schemeClr val="tx1"/>
+              </a:solidFill>
+            </a:endParaRPr>
+          </a:p>
+        </p:txBody>
+      </p:sp>
+      <p:sp>
+        <p:nvSpPr>
+          <p:cNvPr id="2" name="Date Placeholder 4">
+            <a:extLst>
+              <a:ext uri="{FF2B5EF4-FFF2-40B4-BE49-F238E27FC236}">
+                <a16:creationId xmlns:a16="http://schemas.microsoft.com/office/drawing/2014/main" id="{C1C6B9FB-9E6D-7963-D1E9-DADB1518FF68}"/>
+              </a:ext>
+            </a:extLst>
+          </p:cNvPr>
+          <p:cNvSpPr>
+            <a:spLocks noGrp="1"/>
+          </p:cNvSpPr>
+          <p:nvPr>
+            <p:ph type="dt" sz="half" idx="2"/>
+          </p:nvPr>
+        </p:nvSpPr>
+        <p:spPr>
+          <a:xfrm>
+            <a:off x="10436086" y="6556499"/>
+            <a:ext cx="1374913" cy="182799"/>
+          </a:xfrm>
+          <a:prstGeom prst="rect">
+            <a:avLst/>
+          </a:prstGeom>
+        </p:spPr>
+        <p:txBody>
+          <a:bodyPr vert="horz" lIns="91440" tIns="45720" rIns="91440" bIns="45720" rtlCol="0" anchor="ctr"/>
+          <a:lstStyle>
+            <a:lvl1pPr algn="r">
+              <a:defRPr sz="1200" baseline="0">
+                <a:solidFill>
+                  <a:schemeClr val="tx1"/>
+                </a:solidFill>
+              </a:defRPr>
+            </a:lvl1pPr>
+          </a:lstStyle>
+          <a:p>
+            <a:pPr algn="r"/>
+            <a:fld id="{34459720-2A4C-D342-9515-00AC0588A96C}" type="datetimeFigureOut">
+              <a:rPr lang="en-US" smtClean="0"/>
+              <a:pPr/>
+              <a:t>4/22/26</a:t>
+            </a:fld>
+            <a:endParaRPr lang="en-US" dirty="0"/>
+          </a:p>
+        </p:txBody>
+      </p:sp>
+      <p:sp>
+        <p:nvSpPr>
+          <p:cNvPr id="4" name="Footer Placeholder 6">
+            <a:extLst>
+              <a:ext uri="{FF2B5EF4-FFF2-40B4-BE49-F238E27FC236}">
+                <a16:creationId xmlns:a16="http://schemas.microsoft.com/office/drawing/2014/main" id="{91AAE2BC-D897-0CA6-8BBD-AC001562D4C7}"/>
+              </a:ext>
+            </a:extLst>
+          </p:cNvPr>
+          <p:cNvSpPr>
+            <a:spLocks noGrp="1"/>
+          </p:cNvSpPr>
+          <p:nvPr>
+            <p:ph type="ftr" sz="quarter" idx="3"/>
+          </p:nvPr>
+        </p:nvSpPr>
+        <p:spPr>
+          <a:xfrm>
+            <a:off x="555265" y="6556499"/>
+            <a:ext cx="4114800" cy="182799"/>
+          </a:xfrm>
+          <a:prstGeom prst="rect">
+            <a:avLst/>
+          </a:prstGeom>
+        </p:spPr>
+        <p:txBody>
+          <a:bodyPr vert="horz" lIns="91440" tIns="45720" rIns="91440" bIns="45720" rtlCol="0" anchor="ctr"/>
+          <a:lstStyle>
+            <a:lvl1pPr algn="l">
+              <a:defRPr sz="1200" baseline="0">
+                <a:solidFill>
+                  <a:schemeClr val="tx1"/>
+                </a:solidFill>
+              </a:defRPr>
+            </a:lvl1pPr>
+          </a:lstStyle>
+          <a:p>
+            <a:pPr algn="l"/>
+            <a:endParaRPr lang="en-US" dirty="0"/>
+          </a:p>
+        </p:txBody>
+      </p:sp>
+    </p:spTree>
+    <p:extLst>
+      <p:ext uri="{BB962C8B-B14F-4D97-AF65-F5344CB8AC3E}">
+        <p14:creationId xmlns:p14="http://schemas.microsoft.com/office/powerpoint/2010/main" val="338346009"/>
+      </p:ext>
+    </p:extLst>
+  </p:cSld>
+  <p:clrMapOvr>
+    <a:masterClrMapping/>
+  </p:clrMapOvr>
+</p:sldLayout>
+</file>
+
+<file path=ppt/slideLayouts/slideLayout5.xml><?xml version="1.0" encoding="utf-8"?>
+<p:sldLayout xmlns:a="http://schemas.openxmlformats.org/drawingml/2006/main" xmlns:r="http://schemas.openxmlformats.org/officeDocument/2006/relationships" xmlns:p="http://schemas.openxmlformats.org/presentationml/2006/main" type="secHead" preserve="1">
+  <p:cSld name="Section Header">
+    <p:spTree>
+      <p:nvGrpSpPr>
+        <p:cNvPr id="1" name=""/>
+        <p:cNvGrpSpPr/>
+        <p:nvPr/>
+      </p:nvGrpSpPr>
+      <p:grpSpPr>
+        <a:xfrm>
+          <a:off x="0" y="0"/>
+          <a:ext cx="0" cy="0"/>
+          <a:chOff x="0" y="0"/>
+          <a:chExt cx="0" cy="0"/>
+        </a:xfrm>
+      </p:grpSpPr>
+      <p:sp>
+        <p:nvSpPr>
+          <p:cNvPr id="2" name="Title 1"/>
+          <p:cNvSpPr>
+            <a:spLocks noGrp="1"/>
+          </p:cNvSpPr>
+          <p:nvPr>
+            <p:ph type="title"/>
+          </p:nvPr>
+        </p:nvSpPr>
+        <p:spPr>
+          <a:xfrm>
+            <a:off x="609600" y="4406900"/>
+            <a:ext cx="10972800" cy="1371600"/>
+          </a:xfrm>
+          <a:prstGeom prst="rect">
+            <a:avLst/>
+          </a:prstGeom>
+        </p:spPr>
+        <p:txBody>
+          <a:bodyPr anchor="t"/>
+          <a:lstStyle>
+            <a:lvl1pPr algn="l">
+              <a:defRPr sz="4000" b="1" cap="small" baseline="0">
+                <a:solidFill>
+                  <a:schemeClr val="tx1"/>
+                </a:solidFill>
+                <a:latin typeface="Poppins" pitchFamily="2" charset="77"/>
+              </a:defRPr>
+            </a:lvl1pPr>
+          </a:lstStyle>
+          <a:p>
+            <a:r>
+              <a:rPr lang="en-US" dirty="0"/>
+              <a:t>Click to edit Master title style</a:t>
+            </a:r>
+          </a:p>
+        </p:txBody>
+      </p:sp>
+      <p:sp>
+        <p:nvSpPr>
+          <p:cNvPr id="3" name="Text Placeholder 2"/>
+          <p:cNvSpPr>
+            <a:spLocks noGrp="1"/>
+          </p:cNvSpPr>
+          <p:nvPr>
+            <p:ph type="body" idx="1"/>
+          </p:nvPr>
+        </p:nvSpPr>
+        <p:spPr>
+          <a:xfrm>
+            <a:off x="609600" y="2560320"/>
+            <a:ext cx="10972800" cy="1828800"/>
+          </a:xfrm>
+          <a:prstGeom prst="rect">
+            <a:avLst/>
+          </a:prstGeom>
+        </p:spPr>
+        <p:txBody>
+          <a:bodyPr anchor="b"/>
+          <a:lstStyle>
+            <a:lvl1pPr marL="0" indent="0">
+              <a:buNone/>
+              <a:defRPr sz="2000">
+                <a:solidFill>
+                  <a:schemeClr val="tx1">
+                    <a:tint val="75000"/>
+                  </a:schemeClr>
+                </a:solidFill>
+              </a:defRPr>
+            </a:lvl1pPr>
+            <a:lvl2pPr marL="457189" indent="0">
+              <a:buNone/>
+              <a:defRPr sz="1800">
+                <a:solidFill>
+                  <a:schemeClr val="tx1">
+                    <a:tint val="75000"/>
+                  </a:schemeClr>
+                </a:solidFill>
+              </a:defRPr>
+            </a:lvl2pPr>
+            <a:lvl3pPr marL="914377" indent="0">
+              <a:buNone/>
+              <a:defRPr sz="1600">
+                <a:solidFill>
+                  <a:schemeClr val="tx1">
+                    <a:tint val="75000"/>
+                  </a:schemeClr>
+                </a:solidFill>
+              </a:defRPr>
+            </a:lvl3pPr>
+            <a:lvl4pPr marL="1371566" indent="0">
+              <a:buNone/>
+              <a:defRPr sz="1400">
+                <a:solidFill>
+                  <a:schemeClr val="tx1">
+                    <a:tint val="75000"/>
+                  </a:schemeClr>
+                </a:solidFill>
+              </a:defRPr>
+            </a:lvl4pPr>
+            <a:lvl5pPr marL="1828754" indent="0">
+              <a:buNone/>
+              <a:defRPr sz="1400">
+                <a:solidFill>
+                  <a:schemeClr val="tx1">
+                    <a:tint val="75000"/>
+                  </a:schemeClr>
+                </a:solidFill>
+              </a:defRPr>
+            </a:lvl5pPr>
+            <a:lvl6pPr marL="2285943" indent="0">
+              <a:buNone/>
+              <a:defRPr sz="1400">
+                <a:solidFill>
+                  <a:schemeClr val="tx1">
+                    <a:tint val="75000"/>
+                  </a:schemeClr>
+                </a:solidFill>
+              </a:defRPr>
+            </a:lvl6pPr>
+            <a:lvl7pPr marL="2743131" indent="0">
+              <a:buNone/>
+              <a:defRPr sz="1400">
+                <a:solidFill>
+                  <a:schemeClr val="tx1">
+                    <a:tint val="75000"/>
+                  </a:schemeClr>
+                </a:solidFill>
+              </a:defRPr>
+            </a:lvl7pPr>
+            <a:lvl8pPr marL="3200320" indent="0">
+              <a:buNone/>
+              <a:defRPr sz="1400">
+                <a:solidFill>
+                  <a:schemeClr val="tx1">
+                    <a:tint val="75000"/>
+                  </a:schemeClr>
+                </a:solidFill>
+              </a:defRPr>
+            </a:lvl8pPr>
+            <a:lvl9pPr marL="3657509" indent="0">
+              <a:buNone/>
+              <a:defRPr sz="1400">
+                <a:solidFill>
+                  <a:schemeClr val="tx1">
+                    <a:tint val="75000"/>
+                  </a:schemeClr>
+                </a:solidFill>
+              </a:defRPr>
+            </a:lvl9pPr>
+          </a:lstStyle>
+          <a:p>
+            <a:pPr lvl="0"/>
+            <a:r>
+              <a:rPr lang="en-US" dirty="0"/>
+              <a:t>Click to edit Master text styles</a:t>
+            </a:r>
+          </a:p>
+        </p:txBody>
+      </p:sp>
+      <p:sp>
+        <p:nvSpPr>
+          <p:cNvPr id="4" name="Slide Number Placeholder 5">
+            <a:extLst>
+              <a:ext uri="{FF2B5EF4-FFF2-40B4-BE49-F238E27FC236}">
+                <a16:creationId xmlns:a16="http://schemas.microsoft.com/office/drawing/2014/main" id="{FC0B6802-E68E-6161-D5A8-87793D9776EB}"/>
+              </a:ext>
+            </a:extLst>
+          </p:cNvPr>
+          <p:cNvSpPr txBox="1">
+            <a:spLocks/>
+          </p:cNvSpPr>
+          <p:nvPr userDrawn="1"/>
+        </p:nvSpPr>
+        <p:spPr>
+          <a:xfrm>
+            <a:off x="13014" y="6481724"/>
+            <a:ext cx="477640" cy="365125"/>
+          </a:xfrm>
+          <a:prstGeom prst="rect">
+            <a:avLst/>
+          </a:prstGeom>
+        </p:spPr>
+        <p:txBody>
+          <a:bodyPr vert="horz" lIns="91440" tIns="45720" rIns="91440" bIns="45720" rtlCol="0" anchor="ctr"/>
+          <a:lstStyle>
+            <a:defPPr>
+              <a:defRPr lang="en-US"/>
+            </a:defPPr>
+            <a:lvl1pPr marL="0" algn="ctr" defTabSz="609585" rtl="0" eaLnBrk="1" latinLnBrk="0" hangingPunct="1">
+              <a:defRPr sz="1200" kern="1200" baseline="0">
+                <a:solidFill>
+                  <a:schemeClr val="tx1"/>
+                </a:solidFill>
+                <a:latin typeface="+mn-lt"/>
+                <a:ea typeface="+mn-ea"/>
+                <a:cs typeface="+mn-cs"/>
+              </a:defRPr>
+            </a:lvl1pPr>
+            <a:lvl2pPr marL="609585" algn="l" defTabSz="609585" rtl="0" eaLnBrk="1" latinLnBrk="0" hangingPunct="1">
+              <a:defRPr sz="2400" kern="1200">
+                <a:solidFill>
+                  <a:schemeClr val="tx1"/>
+                </a:solidFill>
+                <a:latin typeface="+mn-lt"/>
+                <a:ea typeface="+mn-ea"/>
+                <a:cs typeface="+mn-cs"/>
+              </a:defRPr>
+            </a:lvl2pPr>
+            <a:lvl3pPr marL="1219170" algn="l" defTabSz="609585" rtl="0" eaLnBrk="1" latinLnBrk="0" hangingPunct="1">
+              <a:defRPr sz="2400" kern="1200">
+                <a:solidFill>
+                  <a:schemeClr val="tx1"/>
+                </a:solidFill>
+                <a:latin typeface="+mn-lt"/>
+                <a:ea typeface="+mn-ea"/>
+                <a:cs typeface="+mn-cs"/>
+              </a:defRPr>
+            </a:lvl3pPr>
+            <a:lvl4pPr marL="1828754" algn="l" defTabSz="609585" rtl="0" eaLnBrk="1" latinLnBrk="0" hangingPunct="1">
+              <a:defRPr sz="2400" kern="1200">
+                <a:solidFill>
+                  <a:schemeClr val="tx1"/>
+                </a:solidFill>
+                <a:latin typeface="+mn-lt"/>
+                <a:ea typeface="+mn-ea"/>
+                <a:cs typeface="+mn-cs"/>
+              </a:defRPr>
+            </a:lvl4pPr>
+            <a:lvl5pPr marL="2438339" algn="l" defTabSz="609585" rtl="0" eaLnBrk="1" latinLnBrk="0" hangingPunct="1">
+              <a:defRPr sz="2400" kern="1200">
+                <a:solidFill>
+                  <a:schemeClr val="tx1"/>
+                </a:solidFill>
+                <a:latin typeface="+mn-lt"/>
+                <a:ea typeface="+mn-ea"/>
+                <a:cs typeface="+mn-cs"/>
+              </a:defRPr>
+            </a:lvl5pPr>
+            <a:lvl6pPr marL="3047924" algn="l" defTabSz="609585" rtl="0" eaLnBrk="1" latinLnBrk="0" hangingPunct="1">
+              <a:defRPr sz="2400" kern="1200">
+                <a:solidFill>
+                  <a:schemeClr val="tx1"/>
+                </a:solidFill>
+                <a:latin typeface="+mn-lt"/>
+                <a:ea typeface="+mn-ea"/>
+                <a:cs typeface="+mn-cs"/>
+              </a:defRPr>
+            </a:lvl6pPr>
+            <a:lvl7pPr marL="3657509" algn="l" defTabSz="609585" rtl="0" eaLnBrk="1" latinLnBrk="0" hangingPunct="1">
+              <a:defRPr sz="2400" kern="1200">
+                <a:solidFill>
+                  <a:schemeClr val="tx1"/>
+                </a:solidFill>
+                <a:latin typeface="+mn-lt"/>
+                <a:ea typeface="+mn-ea"/>
+                <a:cs typeface="+mn-cs"/>
+              </a:defRPr>
+            </a:lvl7pPr>
+            <a:lvl8pPr marL="4267093" algn="l" defTabSz="609585" rtl="0" eaLnBrk="1" latinLnBrk="0" hangingPunct="1">
+              <a:defRPr sz="2400" kern="1200">
+                <a:solidFill>
+                  <a:schemeClr val="tx1"/>
+                </a:solidFill>
+                <a:latin typeface="+mn-lt"/>
+                <a:ea typeface="+mn-ea"/>
+                <a:cs typeface="+mn-cs"/>
+              </a:defRPr>
+            </a:lvl8pPr>
+            <a:lvl9pPr marL="4876678" algn="l" defTabSz="609585" rtl="0" eaLnBrk="1" latinLnBrk="0" hangingPunct="1">
+              <a:defRPr sz="2400" kern="1200">
+                <a:solidFill>
+                  <a:schemeClr val="tx1"/>
+                </a:solidFill>
+                <a:latin typeface="+mn-lt"/>
+                <a:ea typeface="+mn-ea"/>
+                <a:cs typeface="+mn-cs"/>
+              </a:defRPr>
+            </a:lvl9pPr>
+          </a:lstStyle>
+          <a:p>
+            <a:fld id="{C5EF2332-01BF-834F-8236-50238282D533}" type="slidenum">
+              <a:rPr lang="en-US" smtClean="0"/>
+              <a:pPr/>
+              <a:t>‹#›</a:t>
+            </a:fld>
+            <a:endParaRPr lang="en-US" dirty="0"/>
+          </a:p>
+        </p:txBody>
+      </p:sp>
+      <p:sp>
+        <p:nvSpPr>
+          <p:cNvPr id="5" name="Date Placeholder 4">
+            <a:extLst>
+              <a:ext uri="{FF2B5EF4-FFF2-40B4-BE49-F238E27FC236}">
+                <a16:creationId xmlns:a16="http://schemas.microsoft.com/office/drawing/2014/main" id="{68A9EDD1-4B41-9FEA-B502-10B14890AC01}"/>
+              </a:ext>
+            </a:extLst>
+          </p:cNvPr>
+          <p:cNvSpPr>
+            <a:spLocks noGrp="1"/>
+          </p:cNvSpPr>
+          <p:nvPr>
+            <p:ph type="dt" sz="half" idx="2"/>
+          </p:nvPr>
+        </p:nvSpPr>
+        <p:spPr>
+          <a:xfrm>
+            <a:off x="10436086" y="6556499"/>
+            <a:ext cx="1374913" cy="182799"/>
+          </a:xfrm>
+          <a:prstGeom prst="rect">
+            <a:avLst/>
+          </a:prstGeom>
+        </p:spPr>
+        <p:txBody>
+          <a:bodyPr vert="horz" lIns="91440" tIns="45720" rIns="91440" bIns="45720" rtlCol="0" anchor="ctr"/>
+          <a:lstStyle>
+            <a:lvl1pPr algn="r">
+              <a:defRPr sz="1200" baseline="0">
+                <a:solidFill>
+                  <a:schemeClr val="tx1"/>
+                </a:solidFill>
+              </a:defRPr>
+            </a:lvl1pPr>
+          </a:lstStyle>
+          <a:p>
+            <a:pPr algn="r"/>
+            <a:fld id="{34459720-2A4C-D342-9515-00AC0588A96C}" type="datetimeFigureOut">
+              <a:rPr lang="en-US" smtClean="0"/>
+              <a:pPr/>
+              <a:t>4/22/26</a:t>
+            </a:fld>
+            <a:endParaRPr lang="en-US" dirty="0"/>
+          </a:p>
+        </p:txBody>
+      </p:sp>
+      <p:sp>
+        <p:nvSpPr>
+          <p:cNvPr id="6" name="Footer Placeholder 6">
+            <a:extLst>
+              <a:ext uri="{FF2B5EF4-FFF2-40B4-BE49-F238E27FC236}">
+                <a16:creationId xmlns:a16="http://schemas.microsoft.com/office/drawing/2014/main" id="{45184FA6-E749-CC87-5ED0-206998A07D57}"/>
+              </a:ext>
+            </a:extLst>
+          </p:cNvPr>
+          <p:cNvSpPr>
+            <a:spLocks noGrp="1"/>
+          </p:cNvSpPr>
+          <p:nvPr>
+            <p:ph type="ftr" sz="quarter" idx="3"/>
+          </p:nvPr>
+        </p:nvSpPr>
+        <p:spPr>
+          <a:xfrm>
+            <a:off x="555265" y="6556499"/>
+            <a:ext cx="4114800" cy="182799"/>
+          </a:xfrm>
+          <a:prstGeom prst="rect">
+            <a:avLst/>
+          </a:prstGeom>
+        </p:spPr>
+        <p:txBody>
+          <a:bodyPr vert="horz" lIns="91440" tIns="45720" rIns="91440" bIns="45720" rtlCol="0" anchor="ctr"/>
+          <a:lstStyle>
+            <a:lvl1pPr algn="l">
+              <a:defRPr sz="1200" baseline="0">
+                <a:solidFill>
+                  <a:schemeClr val="tx1"/>
+                </a:solidFill>
+              </a:defRPr>
+            </a:lvl1pPr>
+          </a:lstStyle>
+          <a:p>
+            <a:pPr algn="l"/>
+            <a:endParaRPr lang="en-US" dirty="0"/>
+          </a:p>
+        </p:txBody>
+      </p:sp>
+    </p:spTree>
+    <p:extLst>
+      <p:ext uri="{BB962C8B-B14F-4D97-AF65-F5344CB8AC3E}">
+        <p14:creationId xmlns:p14="http://schemas.microsoft.com/office/powerpoint/2010/main" val="1073069076"/>
+      </p:ext>
+    </p:extLst>
+  </p:cSld>
+  <p:clrMapOvr>
+    <a:masterClrMapping/>
+  </p:clrMapOvr>
+</p:sldLayout>
+</file>
+
+<file path=ppt/slideLayouts/slideLayout6.xml><?xml version="1.0" encoding="utf-8"?>
+<p:sldLayout xmlns:a="http://schemas.openxmlformats.org/drawingml/2006/main" xmlns:r="http://schemas.openxmlformats.org/officeDocument/2006/relationships" xmlns:p="http://schemas.openxmlformats.org/presentationml/2006/main" type="twoObj" preserve="1">
+  <p:cSld name="Two Content">
+    <p:spTree>
+      <p:nvGrpSpPr>
+        <p:cNvPr id="1" name=""/>
+        <p:cNvGrpSpPr/>
+        <p:nvPr/>
+      </p:nvGrpSpPr>
+      <p:grpSpPr>
+        <a:xfrm>
+          <a:off x="0" y="0"/>
+          <a:ext cx="0" cy="0"/>
+          <a:chOff x="0" y="0"/>
+          <a:chExt cx="0" cy="0"/>
+        </a:xfrm>
+      </p:grpSpPr>
+      <p:sp>
+        <p:nvSpPr>
+          <p:cNvPr id="2" name="Title 1"/>
+          <p:cNvSpPr>
+            <a:spLocks noGrp="1"/>
+          </p:cNvSpPr>
+          <p:nvPr>
+            <p:ph type="title"/>
+          </p:nvPr>
+        </p:nvSpPr>
+        <p:spPr>
+          <a:xfrm>
+            <a:off x="381000" y="0"/>
+            <a:ext cx="9906000" cy="457200"/>
+          </a:xfrm>
+          <a:prstGeom prst="rect">
+            <a:avLst/>
+          </a:prstGeom>
+        </p:spPr>
+        <p:txBody>
+          <a:bodyPr/>
+          <a:lstStyle>
+            <a:lvl1pPr>
+              <a:defRPr baseline="0">
+                <a:solidFill>
+                  <a:schemeClr val="tx1"/>
+                </a:solidFill>
+              </a:defRPr>
+            </a:lvl1pPr>
+          </a:lstStyle>
+          <a:p>
+            <a:r>
+              <a:rPr lang="en-US" dirty="0"/>
+              <a:t>Click to edit Master title style</a:t>
+            </a:r>
+          </a:p>
+        </p:txBody>
+      </p:sp>
+      <p:sp>
+        <p:nvSpPr>
+          <p:cNvPr id="3" name="Content Placeholder 2"/>
+          <p:cNvSpPr>
+            <a:spLocks noGrp="1"/>
+          </p:cNvSpPr>
+          <p:nvPr>
+            <p:ph sz="half" idx="1"/>
+          </p:nvPr>
+        </p:nvSpPr>
+        <p:spPr>
+          <a:xfrm>
+            <a:off x="320040" y="786384"/>
+            <a:ext cx="5715000" cy="5486400"/>
+          </a:xfrm>
+          <a:prstGeom prst="rect">
+            <a:avLst/>
+          </a:prstGeom>
+        </p:spPr>
+        <p:txBody>
+          <a:bodyPr/>
+          <a:lstStyle>
+            <a:lvl1pPr>
+              <a:buNone/>
+              <a:defRPr sz="2800"/>
+            </a:lvl1pPr>
+            <a:lvl2pPr marL="457200" indent="-228600">
+              <a:buFont typeface="Arial" panose="020B0604020202020204" pitchFamily="34" charset="0"/>
+              <a:buChar char="•"/>
+              <a:defRPr sz="2400"/>
+            </a:lvl2pPr>
+            <a:lvl3pPr marL="914400" indent="-228600">
+              <a:buFont typeface="Wingdings" pitchFamily="2" charset="2"/>
+              <a:buChar char="§"/>
+              <a:defRPr sz="2000"/>
+            </a:lvl3pPr>
+            <a:lvl4pPr marL="1371600" indent="-228600">
+              <a:defRPr sz="1800"/>
+            </a:lvl4pPr>
+            <a:lvl5pPr marL="1600200" indent="-228600">
+              <a:defRPr sz="1800"/>
+            </a:lvl5pPr>
+            <a:lvl6pPr>
+              <a:defRPr sz="1800"/>
+            </a:lvl6pPr>
+            <a:lvl7pPr>
+              <a:defRPr sz="1800"/>
+            </a:lvl7pPr>
+            <a:lvl8pPr>
+              <a:defRPr sz="1800"/>
+            </a:lvl8pPr>
+            <a:lvl9pPr>
+              <a:defRPr sz="1800"/>
+            </a:lvl9pPr>
+          </a:lstStyle>
+          <a:p>
+            <a:pPr lvl="0"/>
+            <a:r>
+              <a:rPr lang="en-US" dirty="0"/>
+              <a:t>Click to edit Master text styles</a:t>
+            </a:r>
+          </a:p>
+          <a:p>
+            <a:pPr lvl="1"/>
+            <a:r>
+              <a:rPr lang="en-US" dirty="0"/>
+              <a:t>Second level</a:t>
+            </a:r>
+          </a:p>
+          <a:p>
+            <a:pPr lvl="2"/>
+            <a:r>
+              <a:rPr lang="en-US" dirty="0"/>
+              <a:t>Third level</a:t>
+            </a:r>
+          </a:p>
+          <a:p>
+            <a:pPr lvl="3"/>
+            <a:r>
+              <a:rPr lang="en-US" dirty="0"/>
+              <a:t>Fourth level</a:t>
+            </a:r>
+          </a:p>
+          <a:p>
+            <a:pPr lvl="4"/>
+            <a:r>
+              <a:rPr lang="en-US" dirty="0"/>
+              <a:t>Fifth level</a:t>
+            </a:r>
+          </a:p>
+        </p:txBody>
+      </p:sp>
+      <p:sp>
+        <p:nvSpPr>
+          <p:cNvPr id="4" name="Content Placeholder 3"/>
+          <p:cNvSpPr>
+            <a:spLocks noGrp="1"/>
+          </p:cNvSpPr>
+          <p:nvPr>
+            <p:ph sz="half" idx="2"/>
+          </p:nvPr>
+        </p:nvSpPr>
+        <p:spPr>
+          <a:xfrm>
+            <a:off x="6197600" y="786384"/>
+            <a:ext cx="5715000" cy="5486400"/>
+          </a:xfrm>
+          <a:prstGeom prst="rect">
+            <a:avLst/>
+          </a:prstGeom>
+        </p:spPr>
+        <p:txBody>
+          <a:bodyPr/>
+          <a:lstStyle>
+            <a:lvl1pPr>
+              <a:buNone/>
+              <a:defRPr sz="2800"/>
+            </a:lvl1pPr>
+            <a:lvl2pPr marL="457200" indent="-228600">
+              <a:buFont typeface="Arial" panose="020B0604020202020204" pitchFamily="34" charset="0"/>
+              <a:buChar char="•"/>
+              <a:defRPr sz="2400"/>
+            </a:lvl2pPr>
+            <a:lvl3pPr marL="914400" indent="-228600">
+              <a:buFont typeface="Wingdings" pitchFamily="2" charset="2"/>
+              <a:buChar char="§"/>
+              <a:defRPr sz="2000"/>
+            </a:lvl3pPr>
+            <a:lvl4pPr marL="1371600" indent="-228600">
+              <a:defRPr sz="1800"/>
+            </a:lvl4pPr>
+            <a:lvl5pPr marL="1600200" indent="-228600">
+              <a:defRPr sz="1800"/>
+            </a:lvl5pPr>
+            <a:lvl6pPr>
+              <a:defRPr sz="1800"/>
+            </a:lvl6pPr>
+            <a:lvl7pPr>
+              <a:defRPr sz="1800"/>
+            </a:lvl7pPr>
+            <a:lvl8pPr>
+              <a:defRPr sz="1800"/>
+            </a:lvl8pPr>
+            <a:lvl9pPr>
+              <a:defRPr sz="1800"/>
+            </a:lvl9pPr>
+          </a:lstStyle>
+          <a:p>
+            <a:pPr lvl="0"/>
+            <a:r>
+              <a:rPr lang="en-US" dirty="0"/>
+              <a:t>Click to edit Master text styles</a:t>
+            </a:r>
+          </a:p>
+          <a:p>
+            <a:pPr lvl="1"/>
+            <a:r>
+              <a:rPr lang="en-US" dirty="0"/>
+              <a:t>Second level</a:t>
+            </a:r>
+          </a:p>
+          <a:p>
+            <a:pPr lvl="2"/>
+            <a:r>
+              <a:rPr lang="en-US" dirty="0"/>
+              <a:t>Third level</a:t>
+            </a:r>
+          </a:p>
+          <a:p>
+            <a:pPr lvl="3"/>
+            <a:r>
+              <a:rPr lang="en-US" dirty="0"/>
+              <a:t>Fourth level</a:t>
+            </a:r>
+          </a:p>
+          <a:p>
+            <a:pPr lvl="4"/>
+            <a:r>
+              <a:rPr lang="en-US" dirty="0"/>
+              <a:t>Fifth level</a:t>
+            </a:r>
+          </a:p>
+        </p:txBody>
+      </p:sp>
+      <p:sp>
+        <p:nvSpPr>
+          <p:cNvPr id="6" name="Slide Number Placeholder 5">
+            <a:extLst>
+              <a:ext uri="{FF2B5EF4-FFF2-40B4-BE49-F238E27FC236}">
+                <a16:creationId xmlns:a16="http://schemas.microsoft.com/office/drawing/2014/main" id="{70FEC3C9-9B7B-D61A-73C1-617F8C241600}"/>
+              </a:ext>
+            </a:extLst>
+          </p:cNvPr>
+          <p:cNvSpPr txBox="1">
+            <a:spLocks/>
+          </p:cNvSpPr>
+          <p:nvPr userDrawn="1"/>
+        </p:nvSpPr>
+        <p:spPr>
+          <a:xfrm>
+            <a:off x="13014" y="6481724"/>
+            <a:ext cx="477640" cy="365125"/>
+          </a:xfrm>
+          <a:prstGeom prst="rect">
+            <a:avLst/>
+          </a:prstGeom>
+        </p:spPr>
+        <p:txBody>
+          <a:bodyPr vert="horz" lIns="91440" tIns="45720" rIns="91440" bIns="45720" rtlCol="0" anchor="ctr"/>
+          <a:lstStyle>
+            <a:defPPr>
+              <a:defRPr lang="en-US"/>
+            </a:defPPr>
+            <a:lvl1pPr marL="0" algn="ctr" defTabSz="609585" rtl="0" eaLnBrk="1" latinLnBrk="0" hangingPunct="1">
+              <a:defRPr sz="1200" kern="1200" baseline="0">
+                <a:solidFill>
+                  <a:schemeClr val="tx1"/>
+                </a:solidFill>
+                <a:latin typeface="+mn-lt"/>
+                <a:ea typeface="+mn-ea"/>
+                <a:cs typeface="+mn-cs"/>
+              </a:defRPr>
+            </a:lvl1pPr>
+            <a:lvl2pPr marL="609585" algn="l" defTabSz="609585" rtl="0" eaLnBrk="1" latinLnBrk="0" hangingPunct="1">
+              <a:defRPr sz="2400" kern="1200">
+                <a:solidFill>
+                  <a:schemeClr val="tx1"/>
+                </a:solidFill>
+                <a:latin typeface="+mn-lt"/>
+                <a:ea typeface="+mn-ea"/>
+                <a:cs typeface="+mn-cs"/>
+              </a:defRPr>
+            </a:lvl2pPr>
+            <a:lvl3pPr marL="1219170" algn="l" defTabSz="609585" rtl="0" eaLnBrk="1" latinLnBrk="0" hangingPunct="1">
+              <a:defRPr sz="2400" kern="1200">
+                <a:solidFill>
+                  <a:schemeClr val="tx1"/>
+                </a:solidFill>
+                <a:latin typeface="+mn-lt"/>
+                <a:ea typeface="+mn-ea"/>
+                <a:cs typeface="+mn-cs"/>
+              </a:defRPr>
+            </a:lvl3pPr>
+            <a:lvl4pPr marL="1828754" algn="l" defTabSz="609585" rtl="0" eaLnBrk="1" latinLnBrk="0" hangingPunct="1">
+              <a:defRPr sz="2400" kern="1200">
+                <a:solidFill>
+                  <a:schemeClr val="tx1"/>
+                </a:solidFill>
+                <a:latin typeface="+mn-lt"/>
+                <a:ea typeface="+mn-ea"/>
+                <a:cs typeface="+mn-cs"/>
+              </a:defRPr>
+            </a:lvl4pPr>
+            <a:lvl5pPr marL="2438339" algn="l" defTabSz="609585" rtl="0" eaLnBrk="1" latinLnBrk="0" hangingPunct="1">
+              <a:defRPr sz="2400" kern="1200">
+                <a:solidFill>
+                  <a:schemeClr val="tx1"/>
+                </a:solidFill>
+                <a:latin typeface="+mn-lt"/>
+                <a:ea typeface="+mn-ea"/>
+                <a:cs typeface="+mn-cs"/>
+              </a:defRPr>
+            </a:lvl5pPr>
+            <a:lvl6pPr marL="3047924" algn="l" defTabSz="609585" rtl="0" eaLnBrk="1" latinLnBrk="0" hangingPunct="1">
+              <a:defRPr sz="2400" kern="1200">
+                <a:solidFill>
+                  <a:schemeClr val="tx1"/>
+                </a:solidFill>
+                <a:latin typeface="+mn-lt"/>
+                <a:ea typeface="+mn-ea"/>
+                <a:cs typeface="+mn-cs"/>
+              </a:defRPr>
+            </a:lvl6pPr>
+            <a:lvl7pPr marL="3657509" algn="l" defTabSz="609585" rtl="0" eaLnBrk="1" latinLnBrk="0" hangingPunct="1">
+              <a:defRPr sz="2400" kern="1200">
+                <a:solidFill>
+                  <a:schemeClr val="tx1"/>
+                </a:solidFill>
+                <a:latin typeface="+mn-lt"/>
+                <a:ea typeface="+mn-ea"/>
+                <a:cs typeface="+mn-cs"/>
+              </a:defRPr>
+            </a:lvl7pPr>
+            <a:lvl8pPr marL="4267093" algn="l" defTabSz="609585" rtl="0" eaLnBrk="1" latinLnBrk="0" hangingPunct="1">
+              <a:defRPr sz="2400" kern="1200">
+                <a:solidFill>
+                  <a:schemeClr val="tx1"/>
+                </a:solidFill>
+                <a:latin typeface="+mn-lt"/>
+                <a:ea typeface="+mn-ea"/>
+                <a:cs typeface="+mn-cs"/>
+              </a:defRPr>
+            </a:lvl8pPr>
+            <a:lvl9pPr marL="4876678" algn="l" defTabSz="609585" rtl="0" eaLnBrk="1" latinLnBrk="0" hangingPunct="1">
+              <a:defRPr sz="2400" kern="1200">
+                <a:solidFill>
+                  <a:schemeClr val="tx1"/>
+                </a:solidFill>
+                <a:latin typeface="+mn-lt"/>
+                <a:ea typeface="+mn-ea"/>
+                <a:cs typeface="+mn-cs"/>
+              </a:defRPr>
+            </a:lvl9pPr>
+          </a:lstStyle>
+          <a:p>
+            <a:fld id="{C5EF2332-01BF-834F-8236-50238282D533}" type="slidenum">
+              <a:rPr lang="en-US" smtClean="0"/>
+              <a:pPr/>
+              <a:t>‹#›</a:t>
+            </a:fld>
+            <a:endParaRPr lang="en-US" dirty="0"/>
+          </a:p>
+        </p:txBody>
+      </p:sp>
+      <p:sp>
+        <p:nvSpPr>
+          <p:cNvPr id="5" name="Date Placeholder 4">
+            <a:extLst>
+              <a:ext uri="{FF2B5EF4-FFF2-40B4-BE49-F238E27FC236}">
+                <a16:creationId xmlns:a16="http://schemas.microsoft.com/office/drawing/2014/main" id="{A913B050-A9E8-4587-EAB4-F432AAE36F84}"/>
+              </a:ext>
+            </a:extLst>
+          </p:cNvPr>
+          <p:cNvSpPr>
+            <a:spLocks noGrp="1"/>
+          </p:cNvSpPr>
+          <p:nvPr>
+            <p:ph type="dt" sz="half" idx="10"/>
+          </p:nvPr>
+        </p:nvSpPr>
+        <p:spPr>
+          <a:xfrm>
+            <a:off x="10436086" y="6556499"/>
+            <a:ext cx="1374913" cy="182799"/>
+          </a:xfrm>
+          <a:prstGeom prst="rect">
+            <a:avLst/>
+          </a:prstGeom>
+        </p:spPr>
+        <p:txBody>
+          <a:bodyPr vert="horz" lIns="91440" tIns="45720" rIns="91440" bIns="45720" rtlCol="0" anchor="ctr"/>
+          <a:lstStyle>
+            <a:lvl1pPr algn="r">
+              <a:defRPr sz="1200" baseline="0">
+                <a:solidFill>
+                  <a:schemeClr val="tx1"/>
+                </a:solidFill>
+              </a:defRPr>
+            </a:lvl1pPr>
+          </a:lstStyle>
+          <a:p>
+            <a:pPr algn="r"/>
+            <a:fld id="{34459720-2A4C-D342-9515-00AC0588A96C}" type="datetimeFigureOut">
+              <a:rPr lang="en-US" smtClean="0"/>
+              <a:pPr/>
+              <a:t>4/22/26</a:t>
+            </a:fld>
+            <a:endParaRPr lang="en-US" dirty="0"/>
+          </a:p>
+        </p:txBody>
+      </p:sp>
+      <p:sp>
+        <p:nvSpPr>
+          <p:cNvPr id="7" name="Footer Placeholder 6">
+            <a:extLst>
+              <a:ext uri="{FF2B5EF4-FFF2-40B4-BE49-F238E27FC236}">
+                <a16:creationId xmlns:a16="http://schemas.microsoft.com/office/drawing/2014/main" id="{440B2241-EE2C-B587-40E7-00677B4849AD}"/>
+              </a:ext>
+            </a:extLst>
+          </p:cNvPr>
+          <p:cNvSpPr>
+            <a:spLocks noGrp="1"/>
+          </p:cNvSpPr>
+          <p:nvPr>
+            <p:ph type="ftr" sz="quarter" idx="3"/>
+          </p:nvPr>
+        </p:nvSpPr>
+        <p:spPr>
+          <a:xfrm>
+            <a:off x="555265" y="6556499"/>
+            <a:ext cx="4114800" cy="182799"/>
+          </a:xfrm>
+          <a:prstGeom prst="rect">
+            <a:avLst/>
+          </a:prstGeom>
+        </p:spPr>
+        <p:txBody>
+          <a:bodyPr vert="horz" lIns="91440" tIns="45720" rIns="91440" bIns="45720" rtlCol="0" anchor="ctr"/>
+          <a:lstStyle>
+            <a:lvl1pPr algn="l">
+              <a:defRPr sz="1200" baseline="0">
+                <a:solidFill>
+                  <a:schemeClr val="tx1"/>
+                </a:solidFill>
+              </a:defRPr>
+            </a:lvl1pPr>
+          </a:lstStyle>
+          <a:p>
+            <a:pPr algn="l"/>
+            <a:endParaRPr lang="en-US" dirty="0"/>
+          </a:p>
+        </p:txBody>
+      </p:sp>
+    </p:spTree>
+    <p:extLst>
+      <p:ext uri="{BB962C8B-B14F-4D97-AF65-F5344CB8AC3E}">
+        <p14:creationId xmlns:p14="http://schemas.microsoft.com/office/powerpoint/2010/main" val="2619886245"/>
+      </p:ext>
+    </p:extLst>
+  </p:cSld>
+  <p:clrMapOvr>
+    <a:masterClrMapping/>
+  </p:clrMapOvr>
+</p:sldLayout>
+</file>
+
+<file path=ppt/slideLayouts/slideLayout7.xml><?xml version="1.0" encoding="utf-8"?>
+<p:sldLayout xmlns:a="http://schemas.openxmlformats.org/drawingml/2006/main" xmlns:r="http://schemas.openxmlformats.org/officeDocument/2006/relationships" xmlns:p="http://schemas.openxmlformats.org/presentationml/2006/main" preserve="1" userDrawn="1">
+  <p:cSld name="Comparison">
+    <p:spTree>
+      <p:nvGrpSpPr>
+        <p:cNvPr id="1" name=""/>
+        <p:cNvGrpSpPr/>
+        <p:nvPr/>
+      </p:nvGrpSpPr>
+      <p:grpSpPr>
+        <a:xfrm>
+          <a:off x="0" y="0"/>
+          <a:ext cx="0" cy="0"/>
+          <a:chOff x="0" y="0"/>
+          <a:chExt cx="0" cy="0"/>
+        </a:xfrm>
+      </p:grpSpPr>
+      <p:sp>
+        <p:nvSpPr>
+          <p:cNvPr id="2" name="Title 1"/>
+          <p:cNvSpPr>
+            <a:spLocks noGrp="1"/>
+          </p:cNvSpPr>
+          <p:nvPr>
+            <p:ph type="title"/>
+          </p:nvPr>
+        </p:nvSpPr>
+        <p:spPr>
+          <a:xfrm>
+            <a:off x="381000" y="0"/>
+            <a:ext cx="9906000" cy="457200"/>
+          </a:xfrm>
+          <a:prstGeom prst="rect">
+            <a:avLst/>
+          </a:prstGeom>
+        </p:spPr>
+        <p:txBody>
+          <a:bodyPr/>
+          <a:lstStyle>
+            <a:lvl1pPr>
+              <a:defRPr/>
+            </a:lvl1pPr>
+          </a:lstStyle>
+          <a:p>
+            <a:r>
+              <a:rPr lang="en-US" dirty="0"/>
+              <a:t>Click to edit Master title style</a:t>
+            </a:r>
+          </a:p>
+        </p:txBody>
+      </p:sp>
+      <p:sp>
+        <p:nvSpPr>
+          <p:cNvPr id="3" name="Text Placeholder 2"/>
+          <p:cNvSpPr>
+            <a:spLocks noGrp="1"/>
+          </p:cNvSpPr>
+          <p:nvPr>
+            <p:ph type="body" idx="1"/>
+          </p:nvPr>
+        </p:nvSpPr>
+        <p:spPr>
+          <a:xfrm>
+            <a:off x="320040" y="612147"/>
+            <a:ext cx="5715000" cy="639763"/>
+          </a:xfrm>
+          <a:prstGeom prst="rect">
+            <a:avLst/>
+          </a:prstGeom>
+        </p:spPr>
+        <p:txBody>
+          <a:bodyPr anchor="b"/>
+          <a:lstStyle>
+            <a:lvl1pPr marL="0" indent="0" algn="ctr">
+              <a:buNone/>
+              <a:defRPr sz="2400" b="1"/>
+            </a:lvl1pPr>
+            <a:lvl2pPr marL="457189" indent="0">
+              <a:buNone/>
+              <a:defRPr sz="2000" b="1"/>
+            </a:lvl2pPr>
+            <a:lvl3pPr marL="914377" indent="0">
+              <a:buNone/>
+              <a:defRPr sz="1800" b="1"/>
+            </a:lvl3pPr>
+            <a:lvl4pPr marL="1371566" indent="0">
+              <a:buNone/>
+              <a:defRPr sz="1600" b="1"/>
+            </a:lvl4pPr>
+            <a:lvl5pPr marL="1828754" indent="0">
+              <a:buNone/>
+              <a:defRPr sz="1600" b="1"/>
+            </a:lvl5pPr>
+            <a:lvl6pPr marL="2285943" indent="0">
+              <a:buNone/>
+              <a:defRPr sz="1600" b="1"/>
+            </a:lvl6pPr>
+            <a:lvl7pPr marL="2743131" indent="0">
+              <a:buNone/>
+              <a:defRPr sz="1600" b="1"/>
+            </a:lvl7pPr>
+            <a:lvl8pPr marL="3200320" indent="0">
+              <a:buNone/>
+              <a:defRPr sz="1600" b="1"/>
+            </a:lvl8pPr>
+            <a:lvl9pPr marL="3657509" indent="0">
+              <a:buNone/>
+              <a:defRPr sz="1600" b="1"/>
+            </a:lvl9pPr>
+          </a:lstStyle>
+          <a:p>
+            <a:pPr lvl="0"/>
+            <a:r>
+              <a:rPr lang="en-US" dirty="0"/>
+              <a:t>Click to edit Master text styles</a:t>
+            </a:r>
+          </a:p>
+        </p:txBody>
+      </p:sp>
+      <p:sp>
+        <p:nvSpPr>
+          <p:cNvPr id="5" name="Text Placeholder 4"/>
+          <p:cNvSpPr>
+            <a:spLocks noGrp="1"/>
+          </p:cNvSpPr>
+          <p:nvPr>
+            <p:ph type="body" sz="quarter" idx="3"/>
+          </p:nvPr>
+        </p:nvSpPr>
+        <p:spPr>
+          <a:xfrm>
+            <a:off x="6126480" y="612147"/>
+            <a:ext cx="5715000" cy="639763"/>
+          </a:xfrm>
+          <a:prstGeom prst="rect">
+            <a:avLst/>
+          </a:prstGeom>
+        </p:spPr>
+        <p:txBody>
+          <a:bodyPr anchor="b"/>
+          <a:lstStyle>
+            <a:lvl1pPr marL="0" indent="0" algn="ctr">
+              <a:buNone/>
+              <a:defRPr sz="2400" b="1"/>
+            </a:lvl1pPr>
+            <a:lvl2pPr marL="457189" indent="0">
+              <a:buNone/>
+              <a:defRPr sz="2000" b="1"/>
+            </a:lvl2pPr>
+            <a:lvl3pPr marL="914377" indent="0">
+              <a:buNone/>
+              <a:defRPr sz="1800" b="1"/>
+            </a:lvl3pPr>
+            <a:lvl4pPr marL="1371566" indent="0">
+              <a:buNone/>
+              <a:defRPr sz="1600" b="1"/>
+            </a:lvl4pPr>
+            <a:lvl5pPr marL="1828754" indent="0">
+              <a:buNone/>
+              <a:defRPr sz="1600" b="1"/>
+            </a:lvl5pPr>
+            <a:lvl6pPr marL="2285943" indent="0">
+              <a:buNone/>
+              <a:defRPr sz="1600" b="1"/>
+            </a:lvl6pPr>
+            <a:lvl7pPr marL="2743131" indent="0">
+              <a:buNone/>
+              <a:defRPr sz="1600" b="1"/>
+            </a:lvl7pPr>
+            <a:lvl8pPr marL="3200320" indent="0">
+              <a:buNone/>
+              <a:defRPr sz="1600" b="1"/>
+            </a:lvl8pPr>
+            <a:lvl9pPr marL="3657509" indent="0">
+              <a:buNone/>
+              <a:defRPr sz="1600" b="1"/>
+            </a:lvl9pPr>
+          </a:lstStyle>
+          <a:p>
+            <a:pPr lvl="0"/>
+            <a:r>
+              <a:rPr lang="en-US" dirty="0"/>
+              <a:t>Click to edit Master text styles</a:t>
+            </a:r>
+          </a:p>
+        </p:txBody>
+      </p:sp>
+      <p:sp>
+        <p:nvSpPr>
+          <p:cNvPr id="8" name="Slide Number Placeholder 5">
+            <a:extLst>
+              <a:ext uri="{FF2B5EF4-FFF2-40B4-BE49-F238E27FC236}">
+                <a16:creationId xmlns:a16="http://schemas.microsoft.com/office/drawing/2014/main" id="{C30DE9D8-BF0A-6CD3-1373-CA0B438EB45A}"/>
+              </a:ext>
+            </a:extLst>
+          </p:cNvPr>
+          <p:cNvSpPr>
+            <a:spLocks noGrp="1"/>
+          </p:cNvSpPr>
+          <p:nvPr>
+            <p:ph type="sldNum" sz="quarter" idx="10"/>
+          </p:nvPr>
+        </p:nvSpPr>
+        <p:spPr>
+          <a:xfrm>
+            <a:off x="13014" y="6481724"/>
+            <a:ext cx="477640" cy="365125"/>
+          </a:xfrm>
+          <a:prstGeom prst="rect">
+            <a:avLst/>
+          </a:prstGeom>
+        </p:spPr>
+        <p:txBody>
+          <a:bodyPr vert="horz" lIns="91440" tIns="45720" rIns="91440" bIns="45720" rtlCol="0" anchor="ctr"/>
+          <a:lstStyle>
+            <a:lvl1pPr algn="ctr">
+              <a:defRPr sz="1200" baseline="0">
+                <a:solidFill>
+                  <a:schemeClr val="tx1"/>
+                </a:solidFill>
+              </a:defRPr>
+            </a:lvl1pPr>
+          </a:lstStyle>
+          <a:p>
+            <a:fld id="{C5EF2332-01BF-834F-8236-50238282D533}" type="slidenum">
+              <a:rPr lang="en-US" smtClean="0"/>
+              <a:pPr/>
+              <a:t>‹#›</a:t>
+            </a:fld>
+            <a:endParaRPr lang="en-US" dirty="0">
+              <a:solidFill>
+                <a:schemeClr val="tx1"/>
+              </a:solidFill>
+            </a:endParaRPr>
+          </a:p>
+        </p:txBody>
+      </p:sp>
+      <p:sp>
+        <p:nvSpPr>
+          <p:cNvPr id="10" name="Content Placeholder 2">
+            <a:extLst>
+              <a:ext uri="{FF2B5EF4-FFF2-40B4-BE49-F238E27FC236}">
+                <a16:creationId xmlns:a16="http://schemas.microsoft.com/office/drawing/2014/main" id="{E42C53FE-9BBD-5288-0E88-05B370AA1256}"/>
+              </a:ext>
+            </a:extLst>
+          </p:cNvPr>
+          <p:cNvSpPr>
+            <a:spLocks noGrp="1"/>
+          </p:cNvSpPr>
+          <p:nvPr>
+            <p:ph sz="half" idx="11"/>
+          </p:nvPr>
+        </p:nvSpPr>
+        <p:spPr>
+          <a:xfrm>
+            <a:off x="320040" y="1327868"/>
+            <a:ext cx="5715000" cy="4958632"/>
+          </a:xfrm>
+          <a:prstGeom prst="rect">
+            <a:avLst/>
+          </a:prstGeom>
+        </p:spPr>
+        <p:txBody>
+          <a:bodyPr/>
+          <a:lstStyle>
+            <a:lvl1pPr>
+              <a:buNone/>
+              <a:defRPr sz="2800"/>
+            </a:lvl1pPr>
+            <a:lvl2pPr marL="457200" indent="-228600">
+              <a:buFont typeface="Arial" panose="020B0604020202020204" pitchFamily="34" charset="0"/>
+              <a:buChar char="•"/>
+              <a:defRPr sz="2400"/>
+            </a:lvl2pPr>
+            <a:lvl3pPr marL="914400" indent="-228600">
+              <a:buFont typeface="Wingdings" pitchFamily="2" charset="2"/>
+              <a:buChar char="§"/>
+              <a:defRPr sz="2000"/>
+            </a:lvl3pPr>
+            <a:lvl4pPr marL="1371600" indent="-228600">
+              <a:defRPr sz="1800"/>
+            </a:lvl4pPr>
+            <a:lvl5pPr marL="1600200" indent="-228600">
+              <a:defRPr sz="1800"/>
+            </a:lvl5pPr>
+            <a:lvl6pPr>
+              <a:defRPr sz="1800"/>
+            </a:lvl6pPr>
+            <a:lvl7pPr>
+              <a:defRPr sz="1800"/>
+            </a:lvl7pPr>
+            <a:lvl8pPr>
+              <a:defRPr sz="1800"/>
+            </a:lvl8pPr>
+            <a:lvl9pPr>
+              <a:defRPr sz="1800"/>
+            </a:lvl9pPr>
+          </a:lstStyle>
+          <a:p>
+            <a:pPr lvl="0"/>
+            <a:r>
+              <a:rPr lang="en-US" dirty="0"/>
+              <a:t>Click to edit Master text styles</a:t>
+            </a:r>
+          </a:p>
+          <a:p>
+            <a:pPr lvl="1"/>
+            <a:r>
+              <a:rPr lang="en-US" dirty="0"/>
+              <a:t>Second level</a:t>
+            </a:r>
+          </a:p>
+          <a:p>
+            <a:pPr lvl="2"/>
+            <a:r>
+              <a:rPr lang="en-US" dirty="0"/>
+              <a:t>Third level</a:t>
+            </a:r>
+          </a:p>
+          <a:p>
+            <a:pPr lvl="3"/>
+            <a:r>
+              <a:rPr lang="en-US" dirty="0"/>
+              <a:t>Fourth level</a:t>
+            </a:r>
+          </a:p>
+          <a:p>
+            <a:pPr lvl="4"/>
+            <a:r>
+              <a:rPr lang="en-US" dirty="0"/>
+              <a:t>Fifth level</a:t>
+            </a:r>
+          </a:p>
+        </p:txBody>
+      </p:sp>
+      <p:sp>
+        <p:nvSpPr>
+          <p:cNvPr id="11" name="Content Placeholder 3">
+            <a:extLst>
+              <a:ext uri="{FF2B5EF4-FFF2-40B4-BE49-F238E27FC236}">
+                <a16:creationId xmlns:a16="http://schemas.microsoft.com/office/drawing/2014/main" id="{EC667219-84D4-DAC6-11DF-4C9DA2BDB985}"/>
+              </a:ext>
+            </a:extLst>
+          </p:cNvPr>
+          <p:cNvSpPr>
+            <a:spLocks noGrp="1"/>
+          </p:cNvSpPr>
+          <p:nvPr>
+            <p:ph sz="half" idx="2"/>
+          </p:nvPr>
+        </p:nvSpPr>
+        <p:spPr>
+          <a:xfrm>
+            <a:off x="6126480" y="1327868"/>
+            <a:ext cx="5715000" cy="4958632"/>
+          </a:xfrm>
+          <a:prstGeom prst="rect">
+            <a:avLst/>
+          </a:prstGeom>
+        </p:spPr>
+        <p:txBody>
+          <a:bodyPr/>
+          <a:lstStyle>
+            <a:lvl1pPr>
+              <a:buNone/>
+              <a:defRPr sz="2800"/>
+            </a:lvl1pPr>
+            <a:lvl2pPr marL="457200" indent="-228600">
+              <a:buFont typeface="Arial" panose="020B0604020202020204" pitchFamily="34" charset="0"/>
+              <a:buChar char="•"/>
+              <a:defRPr sz="2400"/>
+            </a:lvl2pPr>
+            <a:lvl3pPr marL="914400" indent="-228600">
+              <a:buFont typeface="Wingdings" pitchFamily="2" charset="2"/>
+              <a:buChar char="§"/>
+              <a:defRPr sz="2000"/>
+            </a:lvl3pPr>
+            <a:lvl4pPr marL="1371600" indent="-228600">
+              <a:defRPr sz="1800"/>
+            </a:lvl4pPr>
+            <a:lvl5pPr marL="1600200" indent="-228600">
+              <a:defRPr sz="1800"/>
+            </a:lvl5pPr>
+            <a:lvl6pPr>
+              <a:defRPr sz="1800"/>
+            </a:lvl6pPr>
+            <a:lvl7pPr>
+              <a:defRPr sz="1800"/>
+            </a:lvl7pPr>
+            <a:lvl8pPr>
+              <a:defRPr sz="1800"/>
+            </a:lvl8pPr>
+            <a:lvl9pPr>
+              <a:defRPr sz="1800"/>
+            </a:lvl9pPr>
+          </a:lstStyle>
+          <a:p>
+            <a:pPr lvl="0"/>
+            <a:r>
+              <a:rPr lang="en-US" dirty="0"/>
+              <a:t>Click to edit Master text styles</a:t>
+            </a:r>
+          </a:p>
+          <a:p>
+            <a:pPr lvl="1"/>
+            <a:r>
+              <a:rPr lang="en-US" dirty="0"/>
+              <a:t>Second level</a:t>
+            </a:r>
+          </a:p>
+          <a:p>
+            <a:pPr lvl="2"/>
+            <a:r>
+              <a:rPr lang="en-US" dirty="0"/>
+              <a:t>Third level</a:t>
+            </a:r>
+          </a:p>
+          <a:p>
+            <a:pPr lvl="3"/>
+            <a:r>
+              <a:rPr lang="en-US" dirty="0"/>
+              <a:t>Fourth level</a:t>
+            </a:r>
+          </a:p>
+          <a:p>
+            <a:pPr lvl="4"/>
+            <a:r>
+              <a:rPr lang="en-US" dirty="0"/>
+              <a:t>Fifth level</a:t>
+            </a:r>
+          </a:p>
+        </p:txBody>
+      </p:sp>
+      <p:sp>
+        <p:nvSpPr>
+          <p:cNvPr id="4" name="Date Placeholder 4">
+            <a:extLst>
+              <a:ext uri="{FF2B5EF4-FFF2-40B4-BE49-F238E27FC236}">
+                <a16:creationId xmlns:a16="http://schemas.microsoft.com/office/drawing/2014/main" id="{8EC862D1-08BD-A013-DA4C-13BF09ED8E2D}"/>
+              </a:ext>
+            </a:extLst>
+          </p:cNvPr>
+          <p:cNvSpPr>
+            <a:spLocks noGrp="1"/>
+          </p:cNvSpPr>
+          <p:nvPr>
+            <p:ph type="dt" sz="half" idx="12"/>
+          </p:nvPr>
+        </p:nvSpPr>
+        <p:spPr>
+          <a:xfrm>
+            <a:off x="10436086" y="6556499"/>
+            <a:ext cx="1374913" cy="182799"/>
+          </a:xfrm>
+          <a:prstGeom prst="rect">
+            <a:avLst/>
+          </a:prstGeom>
+        </p:spPr>
+        <p:txBody>
+          <a:bodyPr vert="horz" lIns="91440" tIns="45720" rIns="91440" bIns="45720" rtlCol="0" anchor="ctr"/>
+          <a:lstStyle>
+            <a:lvl1pPr algn="r">
+              <a:defRPr sz="1200" baseline="0">
+                <a:solidFill>
+                  <a:schemeClr val="tx1"/>
+                </a:solidFill>
+              </a:defRPr>
+            </a:lvl1pPr>
+          </a:lstStyle>
+          <a:p>
+            <a:pPr algn="r"/>
+            <a:fld id="{34459720-2A4C-D342-9515-00AC0588A96C}" type="datetimeFigureOut">
+              <a:rPr lang="en-US" smtClean="0"/>
+              <a:pPr/>
+              <a:t>4/22/26</a:t>
+            </a:fld>
+            <a:endParaRPr lang="en-US" dirty="0"/>
+          </a:p>
+        </p:txBody>
+      </p:sp>
+      <p:sp>
+        <p:nvSpPr>
+          <p:cNvPr id="6" name="Footer Placeholder 6">
+            <a:extLst>
+              <a:ext uri="{FF2B5EF4-FFF2-40B4-BE49-F238E27FC236}">
+                <a16:creationId xmlns:a16="http://schemas.microsoft.com/office/drawing/2014/main" id="{BD18E1DB-680E-BEA6-19A6-D05A67627770}"/>
+              </a:ext>
+            </a:extLst>
+          </p:cNvPr>
+          <p:cNvSpPr>
+            <a:spLocks noGrp="1"/>
+          </p:cNvSpPr>
+          <p:nvPr>
+            <p:ph type="ftr" sz="quarter" idx="13"/>
+          </p:nvPr>
+        </p:nvSpPr>
+        <p:spPr>
+          <a:xfrm>
+            <a:off x="555265" y="6556499"/>
+            <a:ext cx="4114800" cy="182799"/>
+          </a:xfrm>
+          <a:prstGeom prst="rect">
+            <a:avLst/>
+          </a:prstGeom>
+        </p:spPr>
+        <p:txBody>
+          <a:bodyPr vert="horz" lIns="91440" tIns="45720" rIns="91440" bIns="45720" rtlCol="0" anchor="ctr"/>
+          <a:lstStyle>
+            <a:lvl1pPr algn="l">
+              <a:defRPr sz="1200" baseline="0">
+                <a:solidFill>
+                  <a:schemeClr val="tx1"/>
+                </a:solidFill>
+              </a:defRPr>
+            </a:lvl1pPr>
+          </a:lstStyle>
+          <a:p>
+            <a:pPr algn="l"/>
+            <a:endParaRPr lang="en-US" dirty="0"/>
+          </a:p>
+        </p:txBody>
+      </p:sp>
+    </p:spTree>
+    <p:extLst>
+      <p:ext uri="{BB962C8B-B14F-4D97-AF65-F5344CB8AC3E}">
+        <p14:creationId xmlns:p14="http://schemas.microsoft.com/office/powerpoint/2010/main" val="2535793967"/>
+      </p:ext>
+    </p:extLst>
+  </p:cSld>
+  <p:clrMapOvr>
+    <a:masterClrMapping/>
+  </p:clrMapOvr>
+</p:sldLayout>
+</file>
+
+<file path=ppt/slideLayouts/slideLayout8.xml><?xml version="1.0" encoding="utf-8"?>
 <p:sldLayout xmlns:a="http://schemas.openxmlformats.org/drawingml/2006/main" xmlns:r="http://schemas.openxmlformats.org/officeDocument/2006/relationships" xmlns:p="http://schemas.openxmlformats.org/presentationml/2006/main" type="objTx" preserve="1">
   <p:cSld name="Content with Caption">
     <p:spTree>
@@ -1236,8 +3341,8 @@
         </p:nvSpPr>
         <p:spPr>
           <a:xfrm>
-            <a:off x="609602" y="529647"/>
-            <a:ext cx="4011084" cy="1162051"/>
+            <a:off x="609602" y="786384"/>
+            <a:ext cx="4011084" cy="905314"/>
           </a:xfrm>
           <a:prstGeom prst="rect">
             <a:avLst/>
@@ -1270,8 +3375,8 @@
         </p:nvSpPr>
         <p:spPr>
           <a:xfrm>
-            <a:off x="4766733" y="529650"/>
-            <a:ext cx="6815667" cy="5853113"/>
+            <a:off x="4766733" y="786384"/>
+            <a:ext cx="6815667" cy="5486400"/>
           </a:xfrm>
           <a:prstGeom prst="rect">
             <a:avLst/>
@@ -1362,8 +3467,8 @@
         </p:nvSpPr>
         <p:spPr>
           <a:xfrm>
-            <a:off x="609602" y="1691700"/>
-            <a:ext cx="4011084" cy="4691063"/>
+            <a:off x="609602" y="1807029"/>
+            <a:ext cx="4011084" cy="4521324"/>
           </a:xfrm>
           <a:prstGeom prst="rect">
             <a:avLst/>
@@ -1544,6 +3649,95 @@
               <a:pPr/>
               <a:t>‹#›</a:t>
             </a:fld>
+            <a:endParaRPr lang="en-US" dirty="0"/>
+          </a:p>
+        </p:txBody>
+      </p:sp>
+      <p:sp>
+        <p:nvSpPr>
+          <p:cNvPr id="6" name="Date Placeholder 4">
+            <a:extLst>
+              <a:ext uri="{FF2B5EF4-FFF2-40B4-BE49-F238E27FC236}">
+                <a16:creationId xmlns:a16="http://schemas.microsoft.com/office/drawing/2014/main" id="{6C8B6243-C805-5FF2-4848-F6C2B5CAF9EB}"/>
+              </a:ext>
+            </a:extLst>
+          </p:cNvPr>
+          <p:cNvSpPr>
+            <a:spLocks noGrp="1"/>
+          </p:cNvSpPr>
+          <p:nvPr>
+            <p:ph type="dt" sz="half" idx="10"/>
+          </p:nvPr>
+        </p:nvSpPr>
+        <p:spPr>
+          <a:xfrm>
+            <a:off x="10436086" y="6556499"/>
+            <a:ext cx="1374913" cy="182799"/>
+          </a:xfrm>
+          <a:prstGeom prst="rect">
+            <a:avLst/>
+          </a:prstGeom>
+        </p:spPr>
+        <p:txBody>
+          <a:bodyPr vert="horz" lIns="91440" tIns="45720" rIns="91440" bIns="45720" rtlCol="0" anchor="ctr"/>
+          <a:lstStyle>
+            <a:lvl1pPr algn="r">
+              <a:defRPr sz="1200" baseline="0">
+                <a:solidFill>
+                  <a:schemeClr val="tx1"/>
+                </a:solidFill>
+              </a:defRPr>
+            </a:lvl1pPr>
+          </a:lstStyle>
+          <a:p>
+            <a:pPr algn="r"/>
+            <a:fld id="{34459720-2A4C-D342-9515-00AC0588A96C}" type="datetimeFigureOut">
+              <a:rPr lang="en-US" smtClean="0"/>
+              <a:pPr/>
+              <a:t>4/22/26</a:t>
+            </a:fld>
+            <a:endParaRPr lang="en-US" dirty="0"/>
+          </a:p>
+        </p:txBody>
+      </p:sp>
+      <p:sp>
+        <p:nvSpPr>
+          <p:cNvPr id="7" name="Footer Placeholder 6">
+            <a:extLst>
+              <a:ext uri="{FF2B5EF4-FFF2-40B4-BE49-F238E27FC236}">
+                <a16:creationId xmlns:a16="http://schemas.microsoft.com/office/drawing/2014/main" id="{42EAF9C2-F88B-CDBC-6E05-DBA84123693C}"/>
+              </a:ext>
+            </a:extLst>
+          </p:cNvPr>
+          <p:cNvSpPr>
+            <a:spLocks noGrp="1"/>
+          </p:cNvSpPr>
+          <p:nvPr>
+            <p:ph type="ftr" sz="quarter" idx="3"/>
+          </p:nvPr>
+        </p:nvSpPr>
+        <p:spPr>
+          <a:xfrm>
+            <a:off x="555265" y="6556499"/>
+            <a:ext cx="4114800" cy="182799"/>
+          </a:xfrm>
+          <a:prstGeom prst="rect">
+            <a:avLst/>
+          </a:prstGeom>
+        </p:spPr>
+        <p:txBody>
+          <a:bodyPr vert="horz" lIns="91440" tIns="45720" rIns="91440" bIns="45720" rtlCol="0" anchor="ctr"/>
+          <a:lstStyle>
+            <a:lvl1pPr algn="l">
+              <a:defRPr sz="1200" baseline="0">
+                <a:solidFill>
+                  <a:schemeClr val="tx1"/>
+                </a:solidFill>
+              </a:defRPr>
+            </a:lvl1pPr>
+          </a:lstStyle>
+          <a:p>
+            <a:pPr algn="l"/>
             <a:endParaRPr lang="en-US" dirty="0"/>
           </a:p>
         </p:txBody>
@@ -1561,7 +3755,7 @@
 </p:sldLayout>
 </file>
 
-<file path=ppt/slideLayouts/slideLayout11.xml><?xml version="1.0" encoding="utf-8"?>
+<file path=ppt/slideLayouts/slideLayout9.xml><?xml version="1.0" encoding="utf-8"?>
 <p:sldLayout xmlns:a="http://schemas.openxmlformats.org/drawingml/2006/main" xmlns:r="http://schemas.openxmlformats.org/officeDocument/2006/relationships" xmlns:p="http://schemas.openxmlformats.org/presentationml/2006/main" type="picTx" preserve="1">
   <p:cSld name="Picture with Caption">
     <p:spTree>
@@ -1590,7 +3784,7 @@
         </p:nvSpPr>
         <p:spPr>
           <a:xfrm>
-            <a:off x="2389717" y="4800600"/>
+            <a:off x="2389717" y="5159828"/>
             <a:ext cx="7315200" cy="566739"/>
           </a:xfrm>
           <a:prstGeom prst="rect">
@@ -1624,7 +3818,7 @@
         </p:nvSpPr>
         <p:spPr>
           <a:xfrm>
-            <a:off x="2389717" y="612775"/>
+            <a:off x="2389717" y="972003"/>
             <a:ext cx="7315200" cy="4114800"/>
           </a:xfrm>
           <a:prstGeom prst="rect">
@@ -1688,7 +3882,7 @@
         </p:nvSpPr>
         <p:spPr>
           <a:xfrm>
-            <a:off x="2389717" y="5367338"/>
+            <a:off x="2389717" y="5726566"/>
             <a:ext cx="7315200" cy="804863"/>
           </a:xfrm>
           <a:prstGeom prst="rect">
@@ -1874,42 +4068,12 @@
           </a:p>
         </p:txBody>
       </p:sp>
-    </p:spTree>
-    <p:extLst>
-      <p:ext uri="{BB962C8B-B14F-4D97-AF65-F5344CB8AC3E}">
-        <p14:creationId xmlns:p14="http://schemas.microsoft.com/office/powerpoint/2010/main" val="3566899855"/>
-      </p:ext>
-    </p:extLst>
-  </p:cSld>
-  <p:clrMapOvr>
-    <a:masterClrMapping/>
-  </p:clrMapOvr>
-</p:sldLayout>
-</file>
-
-<file path=ppt/slideLayouts/slideLayout2.xml><?xml version="1.0" encoding="utf-8"?>
-<p:sldLayout xmlns:a="http://schemas.openxmlformats.org/drawingml/2006/main" xmlns:r="http://schemas.openxmlformats.org/officeDocument/2006/relationships" xmlns:p="http://schemas.openxmlformats.org/presentationml/2006/main" preserve="1" userDrawn="1">
-  <p:cSld name="Custom Layout">
-    <p:spTree>
-      <p:nvGrpSpPr>
-        <p:cNvPr id="1" name=""/>
-        <p:cNvGrpSpPr/>
-        <p:nvPr/>
-      </p:nvGrpSpPr>
-      <p:grpSpPr>
-        <a:xfrm>
-          <a:off x="0" y="0"/>
-          <a:ext cx="0" cy="0"/>
-          <a:chOff x="0" y="0"/>
-          <a:chExt cx="0" cy="0"/>
-        </a:xfrm>
-      </p:grpSpPr>
-      <p:sp>
-        <p:nvSpPr>
-          <p:cNvPr id="2" name="Title 1">
+      <p:sp>
+        <p:nvSpPr>
+          <p:cNvPr id="6" name="Date Placeholder 4">
             <a:extLst>
               <a:ext uri="{FF2B5EF4-FFF2-40B4-BE49-F238E27FC236}">
-                <a16:creationId xmlns:a16="http://schemas.microsoft.com/office/drawing/2014/main" id="{C6B8646D-489E-60FE-7A18-9CDC45D41807}"/>
+                <a16:creationId xmlns:a16="http://schemas.microsoft.com/office/drawing/2014/main" id="{7AB8E099-8869-8E89-6A26-1DC79410AC0F}"/>
               </a:ext>
             </a:extLst>
           </p:cNvPr>
@@ -1917,27 +4081,46 @@
             <a:spLocks noGrp="1"/>
           </p:cNvSpPr>
           <p:nvPr>
-            <p:ph type="title"/>
+            <p:ph type="dt" sz="half" idx="10"/>
           </p:nvPr>
         </p:nvSpPr>
-        <p:spPr/>
-        <p:txBody>
-          <a:bodyPr/>
-          <a:lstStyle/>
-          <a:p>
-            <a:r>
-              <a:rPr lang="en-US"/>
-              <a:t>Click to edit Master title style</a:t>
-            </a:r>
-          </a:p>
-        </p:txBody>
-      </p:sp>
-      <p:sp>
-        <p:nvSpPr>
-          <p:cNvPr id="3" name="Slide Number Placeholder 2">
+        <p:spPr>
+          <a:xfrm>
+            <a:off x="10436086" y="6556499"/>
+            <a:ext cx="1374913" cy="182799"/>
+          </a:xfrm>
+          <a:prstGeom prst="rect">
+            <a:avLst/>
+          </a:prstGeom>
+        </p:spPr>
+        <p:txBody>
+          <a:bodyPr vert="horz" lIns="91440" tIns="45720" rIns="91440" bIns="45720" rtlCol="0" anchor="ctr"/>
+          <a:lstStyle>
+            <a:lvl1pPr algn="r">
+              <a:defRPr sz="1200" baseline="0">
+                <a:solidFill>
+                  <a:schemeClr val="tx1"/>
+                </a:solidFill>
+              </a:defRPr>
+            </a:lvl1pPr>
+          </a:lstStyle>
+          <a:p>
+            <a:pPr algn="r"/>
+            <a:fld id="{34459720-2A4C-D342-9515-00AC0588A96C}" type="datetimeFigureOut">
+              <a:rPr lang="en-US" smtClean="0"/>
+              <a:pPr/>
+              <a:t>4/22/26</a:t>
+            </a:fld>
+            <a:endParaRPr lang="en-US" dirty="0"/>
+          </a:p>
+        </p:txBody>
+      </p:sp>
+      <p:sp>
+        <p:nvSpPr>
+          <p:cNvPr id="7" name="Footer Placeholder 6">
             <a:extLst>
               <a:ext uri="{FF2B5EF4-FFF2-40B4-BE49-F238E27FC236}">
-                <a16:creationId xmlns:a16="http://schemas.microsoft.com/office/drawing/2014/main" id="{64458514-F400-26C7-7288-45B54DD965FB}"/>
+                <a16:creationId xmlns:a16="http://schemas.microsoft.com/office/drawing/2014/main" id="{E8B2FA44-FACE-7B02-F8EC-E271187398BA}"/>
               </a:ext>
             </a:extLst>
           </p:cNvPr>
@@ -1945,1931 +4128,39 @@
             <a:spLocks noGrp="1"/>
           </p:cNvSpPr>
           <p:nvPr>
-            <p:ph type="sldNum" sz="quarter" idx="10"/>
+            <p:ph type="ftr" sz="quarter" idx="3"/>
           </p:nvPr>
         </p:nvSpPr>
-        <p:spPr/>
-        <p:txBody>
-          <a:bodyPr/>
-          <a:lstStyle/>
-          <a:p>
-            <a:fld id="{C5EF2332-01BF-834F-8236-50238282D533}" type="slidenum">
-              <a:rPr lang="en-US" smtClean="0"/>
-              <a:pPr/>
-              <a:t>‹#›</a:t>
-            </a:fld>
-            <a:endParaRPr lang="en-US" dirty="0">
-              <a:solidFill>
-                <a:schemeClr val="tx1"/>
-              </a:solidFill>
-            </a:endParaRPr>
-          </a:p>
-        </p:txBody>
-      </p:sp>
-      <p:sp>
-        <p:nvSpPr>
-          <p:cNvPr id="4" name="Date Placeholder 3">
-            <a:extLst>
-              <a:ext uri="{FF2B5EF4-FFF2-40B4-BE49-F238E27FC236}">
-                <a16:creationId xmlns:a16="http://schemas.microsoft.com/office/drawing/2014/main" id="{909AA338-C5F6-2612-8A95-BBE47D6054A0}"/>
-              </a:ext>
-            </a:extLst>
-          </p:cNvPr>
-          <p:cNvSpPr>
-            <a:spLocks noGrp="1"/>
-          </p:cNvSpPr>
-          <p:nvPr>
-            <p:ph type="dt" sz="half" idx="11"/>
-          </p:nvPr>
-        </p:nvSpPr>
-        <p:spPr/>
-        <p:txBody>
-          <a:bodyPr/>
-          <a:lstStyle/>
-          <a:p>
-            <a:fld id="{34459720-2A4C-D342-9515-00AC0588A96C}" type="datetimeFigureOut">
-              <a:rPr lang="en-US" smtClean="0"/>
-              <a:t>4/22/26</a:t>
-            </a:fld>
-            <a:endParaRPr lang="en-US"/>
-          </a:p>
-        </p:txBody>
-      </p:sp>
-      <p:sp>
-        <p:nvSpPr>
-          <p:cNvPr id="5" name="Footer Placeholder 4">
-            <a:extLst>
-              <a:ext uri="{FF2B5EF4-FFF2-40B4-BE49-F238E27FC236}">
-                <a16:creationId xmlns:a16="http://schemas.microsoft.com/office/drawing/2014/main" id="{7911FF1B-B65F-DC84-C2A5-47B7C47CA3BD}"/>
-              </a:ext>
-            </a:extLst>
-          </p:cNvPr>
-          <p:cNvSpPr>
-            <a:spLocks noGrp="1"/>
-          </p:cNvSpPr>
-          <p:nvPr>
-            <p:ph type="ftr" sz="quarter" idx="12"/>
-          </p:nvPr>
-        </p:nvSpPr>
-        <p:spPr/>
-        <p:txBody>
-          <a:bodyPr/>
-          <a:lstStyle/>
-          <a:p>
-            <a:endParaRPr lang="en-US"/>
+        <p:spPr>
+          <a:xfrm>
+            <a:off x="555265" y="6556499"/>
+            <a:ext cx="4114800" cy="182799"/>
+          </a:xfrm>
+          <a:prstGeom prst="rect">
+            <a:avLst/>
+          </a:prstGeom>
+        </p:spPr>
+        <p:txBody>
+          <a:bodyPr vert="horz" lIns="91440" tIns="45720" rIns="91440" bIns="45720" rtlCol="0" anchor="ctr"/>
+          <a:lstStyle>
+            <a:lvl1pPr algn="l">
+              <a:defRPr sz="1200" baseline="0">
+                <a:solidFill>
+                  <a:schemeClr val="tx1"/>
+                </a:solidFill>
+              </a:defRPr>
+            </a:lvl1pPr>
+          </a:lstStyle>
+          <a:p>
+            <a:pPr algn="l"/>
+            <a:endParaRPr lang="en-US" dirty="0"/>
           </a:p>
         </p:txBody>
       </p:sp>
     </p:spTree>
     <p:extLst>
       <p:ext uri="{BB962C8B-B14F-4D97-AF65-F5344CB8AC3E}">
-        <p14:creationId xmlns:p14="http://schemas.microsoft.com/office/powerpoint/2010/main" val="2456570876"/>
-      </p:ext>
-    </p:extLst>
-  </p:cSld>
-  <p:clrMapOvr>
-    <a:masterClrMapping/>
-  </p:clrMapOvr>
-</p:sldLayout>
-</file>
-
-<file path=ppt/slideLayouts/slideLayout3.xml><?xml version="1.0" encoding="utf-8"?>
-<p:sldLayout xmlns:a="http://schemas.openxmlformats.org/drawingml/2006/main" xmlns:r="http://schemas.openxmlformats.org/officeDocument/2006/relationships" xmlns:p="http://schemas.openxmlformats.org/presentationml/2006/main" preserve="1" userDrawn="1">
-  <p:cSld name="1_Custom Layout">
-    <p:spTree>
-      <p:nvGrpSpPr>
-        <p:cNvPr id="1" name=""/>
-        <p:cNvGrpSpPr/>
-        <p:nvPr/>
-      </p:nvGrpSpPr>
-      <p:grpSpPr>
-        <a:xfrm>
-          <a:off x="0" y="0"/>
-          <a:ext cx="0" cy="0"/>
-          <a:chOff x="0" y="0"/>
-          <a:chExt cx="0" cy="0"/>
-        </a:xfrm>
-      </p:grpSpPr>
-      <p:sp>
-        <p:nvSpPr>
-          <p:cNvPr id="2" name="Title 1">
-            <a:extLst>
-              <a:ext uri="{FF2B5EF4-FFF2-40B4-BE49-F238E27FC236}">
-                <a16:creationId xmlns:a16="http://schemas.microsoft.com/office/drawing/2014/main" id="{F7C14847-4237-7BDF-70C0-AAA94C873020}"/>
-              </a:ext>
-            </a:extLst>
-          </p:cNvPr>
-          <p:cNvSpPr>
-            <a:spLocks noGrp="1"/>
-          </p:cNvSpPr>
-          <p:nvPr>
-            <p:ph type="title"/>
-          </p:nvPr>
-        </p:nvSpPr>
-        <p:spPr/>
-        <p:txBody>
-          <a:bodyPr/>
-          <a:lstStyle/>
-          <a:p>
-            <a:r>
-              <a:rPr lang="en-US"/>
-              <a:t>Click to edit Master title style</a:t>
-            </a:r>
-          </a:p>
-        </p:txBody>
-      </p:sp>
-      <p:sp>
-        <p:nvSpPr>
-          <p:cNvPr id="3" name="Slide Number Placeholder 2">
-            <a:extLst>
-              <a:ext uri="{FF2B5EF4-FFF2-40B4-BE49-F238E27FC236}">
-                <a16:creationId xmlns:a16="http://schemas.microsoft.com/office/drawing/2014/main" id="{2B02A162-63A5-5FD0-D699-121DE3B72EFB}"/>
-              </a:ext>
-            </a:extLst>
-          </p:cNvPr>
-          <p:cNvSpPr>
-            <a:spLocks noGrp="1"/>
-          </p:cNvSpPr>
-          <p:nvPr>
-            <p:ph type="sldNum" sz="quarter" idx="10"/>
-          </p:nvPr>
-        </p:nvSpPr>
-        <p:spPr/>
-        <p:txBody>
-          <a:bodyPr/>
-          <a:lstStyle/>
-          <a:p>
-            <a:fld id="{C5EF2332-01BF-834F-8236-50238282D533}" type="slidenum">
-              <a:rPr lang="en-US" smtClean="0"/>
-              <a:pPr/>
-              <a:t>‹#›</a:t>
-            </a:fld>
-            <a:endParaRPr lang="en-US" dirty="0">
-              <a:solidFill>
-                <a:schemeClr val="tx1"/>
-              </a:solidFill>
-            </a:endParaRPr>
-          </a:p>
-        </p:txBody>
-      </p:sp>
-      <p:sp>
-        <p:nvSpPr>
-          <p:cNvPr id="4" name="Date Placeholder 3">
-            <a:extLst>
-              <a:ext uri="{FF2B5EF4-FFF2-40B4-BE49-F238E27FC236}">
-                <a16:creationId xmlns:a16="http://schemas.microsoft.com/office/drawing/2014/main" id="{E686C1D3-C861-797E-453C-F2A982E2C380}"/>
-              </a:ext>
-            </a:extLst>
-          </p:cNvPr>
-          <p:cNvSpPr>
-            <a:spLocks noGrp="1"/>
-          </p:cNvSpPr>
-          <p:nvPr>
-            <p:ph type="dt" sz="half" idx="11"/>
-          </p:nvPr>
-        </p:nvSpPr>
-        <p:spPr/>
-        <p:txBody>
-          <a:bodyPr/>
-          <a:lstStyle/>
-          <a:p>
-            <a:fld id="{34459720-2A4C-D342-9515-00AC0588A96C}" type="datetimeFigureOut">
-              <a:rPr lang="en-US" smtClean="0"/>
-              <a:t>4/22/26</a:t>
-            </a:fld>
-            <a:endParaRPr lang="en-US"/>
-          </a:p>
-        </p:txBody>
-      </p:sp>
-      <p:sp>
-        <p:nvSpPr>
-          <p:cNvPr id="5" name="Footer Placeholder 4">
-            <a:extLst>
-              <a:ext uri="{FF2B5EF4-FFF2-40B4-BE49-F238E27FC236}">
-                <a16:creationId xmlns:a16="http://schemas.microsoft.com/office/drawing/2014/main" id="{486E43C0-10FD-FCC8-E6E1-B175D77AA62A}"/>
-              </a:ext>
-            </a:extLst>
-          </p:cNvPr>
-          <p:cNvSpPr>
-            <a:spLocks noGrp="1"/>
-          </p:cNvSpPr>
-          <p:nvPr>
-            <p:ph type="ftr" sz="quarter" idx="12"/>
-          </p:nvPr>
-        </p:nvSpPr>
-        <p:spPr/>
-        <p:txBody>
-          <a:bodyPr/>
-          <a:lstStyle/>
-          <a:p>
-            <a:endParaRPr lang="en-US"/>
-          </a:p>
-        </p:txBody>
-      </p:sp>
-    </p:spTree>
-    <p:extLst>
-      <p:ext uri="{BB962C8B-B14F-4D97-AF65-F5344CB8AC3E}">
-        <p14:creationId xmlns:p14="http://schemas.microsoft.com/office/powerpoint/2010/main" val="2949212871"/>
-      </p:ext>
-    </p:extLst>
-  </p:cSld>
-  <p:clrMapOvr>
-    <a:masterClrMapping/>
-  </p:clrMapOvr>
-</p:sldLayout>
-</file>
-
-<file path=ppt/slideLayouts/slideLayout4.xml><?xml version="1.0" encoding="utf-8"?>
-<p:sldLayout xmlns:a="http://schemas.openxmlformats.org/drawingml/2006/main" xmlns:r="http://schemas.openxmlformats.org/officeDocument/2006/relationships" xmlns:p="http://schemas.openxmlformats.org/presentationml/2006/main" preserve="1" userDrawn="1">
-  <p:cSld name="Title and Content">
-    <p:spTree>
-      <p:nvGrpSpPr>
-        <p:cNvPr id="1" name=""/>
-        <p:cNvGrpSpPr/>
-        <p:nvPr/>
-      </p:nvGrpSpPr>
-      <p:grpSpPr>
-        <a:xfrm>
-          <a:off x="0" y="0"/>
-          <a:ext cx="0" cy="0"/>
-          <a:chOff x="0" y="0"/>
-          <a:chExt cx="0" cy="0"/>
-        </a:xfrm>
-      </p:grpSpPr>
-      <p:sp>
-        <p:nvSpPr>
-          <p:cNvPr id="3" name="Content Placeholder 2"/>
-          <p:cNvSpPr>
-            <a:spLocks noGrp="1"/>
-          </p:cNvSpPr>
-          <p:nvPr>
-            <p:ph idx="1"/>
-          </p:nvPr>
-        </p:nvSpPr>
-        <p:spPr>
-          <a:xfrm>
-            <a:off x="381000" y="571500"/>
-            <a:ext cx="11430000" cy="5715000"/>
-          </a:xfrm>
-          <a:prstGeom prst="rect">
-            <a:avLst/>
-          </a:prstGeom>
-        </p:spPr>
-        <p:txBody>
-          <a:bodyPr/>
-          <a:lstStyle>
-            <a:lvl1pPr marL="228600" indent="-228600">
-              <a:buClrTx/>
-              <a:buFontTx/>
-              <a:buNone/>
-              <a:defRPr baseline="0">
-                <a:latin typeface="Poppins" pitchFamily="2" charset="77"/>
-              </a:defRPr>
-            </a:lvl1pPr>
-            <a:lvl2pPr marL="457200" indent="-228600">
-              <a:buFont typeface="Arial" panose="020B0604020202020204" pitchFamily="34" charset="0"/>
-              <a:buChar char="•"/>
-              <a:defRPr baseline="0"/>
-            </a:lvl2pPr>
-            <a:lvl3pPr marL="914400" indent="-228600">
-              <a:buFont typeface="Wingdings" pitchFamily="2" charset="2"/>
-              <a:buChar char="§"/>
-              <a:defRPr baseline="0"/>
-            </a:lvl3pPr>
-            <a:lvl4pPr marL="1371600" indent="-228600">
-              <a:defRPr baseline="0"/>
-            </a:lvl4pPr>
-            <a:lvl5pPr marL="1828800" indent="-228600">
-              <a:defRPr baseline="0"/>
-            </a:lvl5pPr>
-          </a:lstStyle>
-          <a:p>
-            <a:pPr lvl="0"/>
-            <a:endParaRPr lang="en-US" dirty="0"/>
-          </a:p>
-          <a:p>
-            <a:pPr lvl="0"/>
-            <a:r>
-              <a:rPr lang="en-US" dirty="0"/>
-              <a:t>Click to edit Master text styles</a:t>
-            </a:r>
-          </a:p>
-          <a:p>
-            <a:pPr lvl="1"/>
-            <a:r>
-              <a:rPr lang="en-US" dirty="0"/>
-              <a:t>Second level</a:t>
-            </a:r>
-          </a:p>
-          <a:p>
-            <a:pPr lvl="2"/>
-            <a:r>
-              <a:rPr lang="en-US" dirty="0"/>
-              <a:t>Third level</a:t>
-            </a:r>
-          </a:p>
-          <a:p>
-            <a:pPr lvl="3"/>
-            <a:r>
-              <a:rPr lang="en-US" dirty="0"/>
-              <a:t>Fourth level</a:t>
-            </a:r>
-          </a:p>
-          <a:p>
-            <a:pPr lvl="4"/>
-            <a:r>
-              <a:rPr lang="en-US" dirty="0"/>
-              <a:t>Fifth level</a:t>
-            </a:r>
-          </a:p>
-        </p:txBody>
-      </p:sp>
-      <p:sp>
-        <p:nvSpPr>
-          <p:cNvPr id="10" name="Title 8">
-            <a:extLst>
-              <a:ext uri="{FF2B5EF4-FFF2-40B4-BE49-F238E27FC236}">
-                <a16:creationId xmlns:a16="http://schemas.microsoft.com/office/drawing/2014/main" id="{16C1CE93-3040-4E7C-AF01-3DC2EF8F8C7E}"/>
-              </a:ext>
-            </a:extLst>
-          </p:cNvPr>
-          <p:cNvSpPr>
-            <a:spLocks noGrp="1"/>
-          </p:cNvSpPr>
-          <p:nvPr>
-            <p:ph type="title"/>
-          </p:nvPr>
-        </p:nvSpPr>
-        <p:spPr>
-          <a:xfrm>
-            <a:off x="381000" y="0"/>
-            <a:ext cx="9905999" cy="457200"/>
-          </a:xfrm>
-        </p:spPr>
-        <p:txBody>
-          <a:bodyPr/>
-          <a:lstStyle/>
-          <a:p>
-            <a:r>
-              <a:rPr lang="en-US" dirty="0"/>
-              <a:t>Click to edit Master title style</a:t>
-            </a:r>
-          </a:p>
-        </p:txBody>
-      </p:sp>
-      <p:sp>
-        <p:nvSpPr>
-          <p:cNvPr id="11" name="Slide Number Placeholder 5">
-            <a:extLst>
-              <a:ext uri="{FF2B5EF4-FFF2-40B4-BE49-F238E27FC236}">
-                <a16:creationId xmlns:a16="http://schemas.microsoft.com/office/drawing/2014/main" id="{6AFDE7CA-02E9-BF8D-B70C-37475DB92919}"/>
-              </a:ext>
-            </a:extLst>
-          </p:cNvPr>
-          <p:cNvSpPr>
-            <a:spLocks noGrp="1"/>
-          </p:cNvSpPr>
-          <p:nvPr>
-            <p:ph type="sldNum" sz="quarter" idx="4"/>
-          </p:nvPr>
-        </p:nvSpPr>
-        <p:spPr>
-          <a:xfrm>
-            <a:off x="13014" y="6481724"/>
-            <a:ext cx="477640" cy="365125"/>
-          </a:xfrm>
-          <a:prstGeom prst="rect">
-            <a:avLst/>
-          </a:prstGeom>
-        </p:spPr>
-        <p:txBody>
-          <a:bodyPr vert="horz" lIns="91440" tIns="45720" rIns="91440" bIns="45720" rtlCol="0" anchor="ctr"/>
-          <a:lstStyle>
-            <a:lvl1pPr algn="ctr">
-              <a:defRPr sz="1200" baseline="0">
-                <a:solidFill>
-                  <a:schemeClr val="tx1"/>
-                </a:solidFill>
-              </a:defRPr>
-            </a:lvl1pPr>
-          </a:lstStyle>
-          <a:p>
-            <a:fld id="{C5EF2332-01BF-834F-8236-50238282D533}" type="slidenum">
-              <a:rPr lang="en-US" smtClean="0"/>
-              <a:pPr/>
-              <a:t>‹#›</a:t>
-            </a:fld>
-            <a:endParaRPr lang="en-US" dirty="0">
-              <a:solidFill>
-                <a:schemeClr val="tx1"/>
-              </a:solidFill>
-            </a:endParaRPr>
-          </a:p>
-        </p:txBody>
-      </p:sp>
-    </p:spTree>
-    <p:extLst>
-      <p:ext uri="{BB962C8B-B14F-4D97-AF65-F5344CB8AC3E}">
-        <p14:creationId xmlns:p14="http://schemas.microsoft.com/office/powerpoint/2010/main" val="338346009"/>
-      </p:ext>
-    </p:extLst>
-  </p:cSld>
-  <p:clrMapOvr>
-    <a:masterClrMapping/>
-  </p:clrMapOvr>
-</p:sldLayout>
-</file>
-
-<file path=ppt/slideLayouts/slideLayout5.xml><?xml version="1.0" encoding="utf-8"?>
-<p:sldLayout xmlns:a="http://schemas.openxmlformats.org/drawingml/2006/main" xmlns:r="http://schemas.openxmlformats.org/officeDocument/2006/relationships" xmlns:p="http://schemas.openxmlformats.org/presentationml/2006/main" type="secHead" preserve="1">
-  <p:cSld name="Section Header">
-    <p:spTree>
-      <p:nvGrpSpPr>
-        <p:cNvPr id="1" name=""/>
-        <p:cNvGrpSpPr/>
-        <p:nvPr/>
-      </p:nvGrpSpPr>
-      <p:grpSpPr>
-        <a:xfrm>
-          <a:off x="0" y="0"/>
-          <a:ext cx="0" cy="0"/>
-          <a:chOff x="0" y="0"/>
-          <a:chExt cx="0" cy="0"/>
-        </a:xfrm>
-      </p:grpSpPr>
-      <p:sp>
-        <p:nvSpPr>
-          <p:cNvPr id="2" name="Title 1"/>
-          <p:cNvSpPr>
-            <a:spLocks noGrp="1"/>
-          </p:cNvSpPr>
-          <p:nvPr>
-            <p:ph type="title"/>
-          </p:nvPr>
-        </p:nvSpPr>
-        <p:spPr>
-          <a:xfrm>
-            <a:off x="609600" y="4406900"/>
-            <a:ext cx="10972800" cy="1371600"/>
-          </a:xfrm>
-          <a:prstGeom prst="rect">
-            <a:avLst/>
-          </a:prstGeom>
-        </p:spPr>
-        <p:txBody>
-          <a:bodyPr anchor="t"/>
-          <a:lstStyle>
-            <a:lvl1pPr algn="l">
-              <a:defRPr sz="4000" b="1" cap="small" baseline="0">
-                <a:solidFill>
-                  <a:schemeClr val="tx1"/>
-                </a:solidFill>
-                <a:latin typeface="Poppins" pitchFamily="2" charset="77"/>
-              </a:defRPr>
-            </a:lvl1pPr>
-          </a:lstStyle>
-          <a:p>
-            <a:r>
-              <a:rPr lang="en-US" dirty="0"/>
-              <a:t>Click to edit Master title style</a:t>
-            </a:r>
-          </a:p>
-        </p:txBody>
-      </p:sp>
-      <p:sp>
-        <p:nvSpPr>
-          <p:cNvPr id="3" name="Text Placeholder 2"/>
-          <p:cNvSpPr>
-            <a:spLocks noGrp="1"/>
-          </p:cNvSpPr>
-          <p:nvPr>
-            <p:ph type="body" idx="1"/>
-          </p:nvPr>
-        </p:nvSpPr>
-        <p:spPr>
-          <a:xfrm>
-            <a:off x="609600" y="2560320"/>
-            <a:ext cx="10972800" cy="1828800"/>
-          </a:xfrm>
-          <a:prstGeom prst="rect">
-            <a:avLst/>
-          </a:prstGeom>
-        </p:spPr>
-        <p:txBody>
-          <a:bodyPr anchor="b"/>
-          <a:lstStyle>
-            <a:lvl1pPr marL="0" indent="0">
-              <a:buNone/>
-              <a:defRPr sz="2000">
-                <a:solidFill>
-                  <a:schemeClr val="tx1">
-                    <a:tint val="75000"/>
-                  </a:schemeClr>
-                </a:solidFill>
-              </a:defRPr>
-            </a:lvl1pPr>
-            <a:lvl2pPr marL="457189" indent="0">
-              <a:buNone/>
-              <a:defRPr sz="1800">
-                <a:solidFill>
-                  <a:schemeClr val="tx1">
-                    <a:tint val="75000"/>
-                  </a:schemeClr>
-                </a:solidFill>
-              </a:defRPr>
-            </a:lvl2pPr>
-            <a:lvl3pPr marL="914377" indent="0">
-              <a:buNone/>
-              <a:defRPr sz="1600">
-                <a:solidFill>
-                  <a:schemeClr val="tx1">
-                    <a:tint val="75000"/>
-                  </a:schemeClr>
-                </a:solidFill>
-              </a:defRPr>
-            </a:lvl3pPr>
-            <a:lvl4pPr marL="1371566" indent="0">
-              <a:buNone/>
-              <a:defRPr sz="1400">
-                <a:solidFill>
-                  <a:schemeClr val="tx1">
-                    <a:tint val="75000"/>
-                  </a:schemeClr>
-                </a:solidFill>
-              </a:defRPr>
-            </a:lvl4pPr>
-            <a:lvl5pPr marL="1828754" indent="0">
-              <a:buNone/>
-              <a:defRPr sz="1400">
-                <a:solidFill>
-                  <a:schemeClr val="tx1">
-                    <a:tint val="75000"/>
-                  </a:schemeClr>
-                </a:solidFill>
-              </a:defRPr>
-            </a:lvl5pPr>
-            <a:lvl6pPr marL="2285943" indent="0">
-              <a:buNone/>
-              <a:defRPr sz="1400">
-                <a:solidFill>
-                  <a:schemeClr val="tx1">
-                    <a:tint val="75000"/>
-                  </a:schemeClr>
-                </a:solidFill>
-              </a:defRPr>
-            </a:lvl6pPr>
-            <a:lvl7pPr marL="2743131" indent="0">
-              <a:buNone/>
-              <a:defRPr sz="1400">
-                <a:solidFill>
-                  <a:schemeClr val="tx1">
-                    <a:tint val="75000"/>
-                  </a:schemeClr>
-                </a:solidFill>
-              </a:defRPr>
-            </a:lvl7pPr>
-            <a:lvl8pPr marL="3200320" indent="0">
-              <a:buNone/>
-              <a:defRPr sz="1400">
-                <a:solidFill>
-                  <a:schemeClr val="tx1">
-                    <a:tint val="75000"/>
-                  </a:schemeClr>
-                </a:solidFill>
-              </a:defRPr>
-            </a:lvl8pPr>
-            <a:lvl9pPr marL="3657509" indent="0">
-              <a:buNone/>
-              <a:defRPr sz="1400">
-                <a:solidFill>
-                  <a:schemeClr val="tx1">
-                    <a:tint val="75000"/>
-                  </a:schemeClr>
-                </a:solidFill>
-              </a:defRPr>
-            </a:lvl9pPr>
-          </a:lstStyle>
-          <a:p>
-            <a:pPr lvl="0"/>
-            <a:r>
-              <a:rPr lang="en-US" dirty="0"/>
-              <a:t>Click to edit Master text styles</a:t>
-            </a:r>
-          </a:p>
-        </p:txBody>
-      </p:sp>
-      <p:sp>
-        <p:nvSpPr>
-          <p:cNvPr id="4" name="Slide Number Placeholder 5">
-            <a:extLst>
-              <a:ext uri="{FF2B5EF4-FFF2-40B4-BE49-F238E27FC236}">
-                <a16:creationId xmlns:a16="http://schemas.microsoft.com/office/drawing/2014/main" id="{FC0B6802-E68E-6161-D5A8-87793D9776EB}"/>
-              </a:ext>
-            </a:extLst>
-          </p:cNvPr>
-          <p:cNvSpPr txBox="1">
-            <a:spLocks/>
-          </p:cNvSpPr>
-          <p:nvPr userDrawn="1"/>
-        </p:nvSpPr>
-        <p:spPr>
-          <a:xfrm>
-            <a:off x="13014" y="6481724"/>
-            <a:ext cx="477640" cy="365125"/>
-          </a:xfrm>
-          <a:prstGeom prst="rect">
-            <a:avLst/>
-          </a:prstGeom>
-        </p:spPr>
-        <p:txBody>
-          <a:bodyPr vert="horz" lIns="91440" tIns="45720" rIns="91440" bIns="45720" rtlCol="0" anchor="ctr"/>
-          <a:lstStyle>
-            <a:defPPr>
-              <a:defRPr lang="en-US"/>
-            </a:defPPr>
-            <a:lvl1pPr marL="0" algn="ctr" defTabSz="609585" rtl="0" eaLnBrk="1" latinLnBrk="0" hangingPunct="1">
-              <a:defRPr sz="1200" kern="1200" baseline="0">
-                <a:solidFill>
-                  <a:schemeClr val="tx1"/>
-                </a:solidFill>
-                <a:latin typeface="+mn-lt"/>
-                <a:ea typeface="+mn-ea"/>
-                <a:cs typeface="+mn-cs"/>
-              </a:defRPr>
-            </a:lvl1pPr>
-            <a:lvl2pPr marL="609585" algn="l" defTabSz="609585" rtl="0" eaLnBrk="1" latinLnBrk="0" hangingPunct="1">
-              <a:defRPr sz="2400" kern="1200">
-                <a:solidFill>
-                  <a:schemeClr val="tx1"/>
-                </a:solidFill>
-                <a:latin typeface="+mn-lt"/>
-                <a:ea typeface="+mn-ea"/>
-                <a:cs typeface="+mn-cs"/>
-              </a:defRPr>
-            </a:lvl2pPr>
-            <a:lvl3pPr marL="1219170" algn="l" defTabSz="609585" rtl="0" eaLnBrk="1" latinLnBrk="0" hangingPunct="1">
-              <a:defRPr sz="2400" kern="1200">
-                <a:solidFill>
-                  <a:schemeClr val="tx1"/>
-                </a:solidFill>
-                <a:latin typeface="+mn-lt"/>
-                <a:ea typeface="+mn-ea"/>
-                <a:cs typeface="+mn-cs"/>
-              </a:defRPr>
-            </a:lvl3pPr>
-            <a:lvl4pPr marL="1828754" algn="l" defTabSz="609585" rtl="0" eaLnBrk="1" latinLnBrk="0" hangingPunct="1">
-              <a:defRPr sz="2400" kern="1200">
-                <a:solidFill>
-                  <a:schemeClr val="tx1"/>
-                </a:solidFill>
-                <a:latin typeface="+mn-lt"/>
-                <a:ea typeface="+mn-ea"/>
-                <a:cs typeface="+mn-cs"/>
-              </a:defRPr>
-            </a:lvl4pPr>
-            <a:lvl5pPr marL="2438339" algn="l" defTabSz="609585" rtl="0" eaLnBrk="1" latinLnBrk="0" hangingPunct="1">
-              <a:defRPr sz="2400" kern="1200">
-                <a:solidFill>
-                  <a:schemeClr val="tx1"/>
-                </a:solidFill>
-                <a:latin typeface="+mn-lt"/>
-                <a:ea typeface="+mn-ea"/>
-                <a:cs typeface="+mn-cs"/>
-              </a:defRPr>
-            </a:lvl5pPr>
-            <a:lvl6pPr marL="3047924" algn="l" defTabSz="609585" rtl="0" eaLnBrk="1" latinLnBrk="0" hangingPunct="1">
-              <a:defRPr sz="2400" kern="1200">
-                <a:solidFill>
-                  <a:schemeClr val="tx1"/>
-                </a:solidFill>
-                <a:latin typeface="+mn-lt"/>
-                <a:ea typeface="+mn-ea"/>
-                <a:cs typeface="+mn-cs"/>
-              </a:defRPr>
-            </a:lvl6pPr>
-            <a:lvl7pPr marL="3657509" algn="l" defTabSz="609585" rtl="0" eaLnBrk="1" latinLnBrk="0" hangingPunct="1">
-              <a:defRPr sz="2400" kern="1200">
-                <a:solidFill>
-                  <a:schemeClr val="tx1"/>
-                </a:solidFill>
-                <a:latin typeface="+mn-lt"/>
-                <a:ea typeface="+mn-ea"/>
-                <a:cs typeface="+mn-cs"/>
-              </a:defRPr>
-            </a:lvl7pPr>
-            <a:lvl8pPr marL="4267093" algn="l" defTabSz="609585" rtl="0" eaLnBrk="1" latinLnBrk="0" hangingPunct="1">
-              <a:defRPr sz="2400" kern="1200">
-                <a:solidFill>
-                  <a:schemeClr val="tx1"/>
-                </a:solidFill>
-                <a:latin typeface="+mn-lt"/>
-                <a:ea typeface="+mn-ea"/>
-                <a:cs typeface="+mn-cs"/>
-              </a:defRPr>
-            </a:lvl8pPr>
-            <a:lvl9pPr marL="4876678" algn="l" defTabSz="609585" rtl="0" eaLnBrk="1" latinLnBrk="0" hangingPunct="1">
-              <a:defRPr sz="2400" kern="1200">
-                <a:solidFill>
-                  <a:schemeClr val="tx1"/>
-                </a:solidFill>
-                <a:latin typeface="+mn-lt"/>
-                <a:ea typeface="+mn-ea"/>
-                <a:cs typeface="+mn-cs"/>
-              </a:defRPr>
-            </a:lvl9pPr>
-          </a:lstStyle>
-          <a:p>
-            <a:fld id="{C5EF2332-01BF-834F-8236-50238282D533}" type="slidenum">
-              <a:rPr lang="en-US" smtClean="0"/>
-              <a:pPr/>
-              <a:t>‹#›</a:t>
-            </a:fld>
-            <a:endParaRPr lang="en-US" dirty="0"/>
-          </a:p>
-        </p:txBody>
-      </p:sp>
-    </p:spTree>
-    <p:extLst>
-      <p:ext uri="{BB962C8B-B14F-4D97-AF65-F5344CB8AC3E}">
-        <p14:creationId xmlns:p14="http://schemas.microsoft.com/office/powerpoint/2010/main" val="1073069076"/>
-      </p:ext>
-    </p:extLst>
-  </p:cSld>
-  <p:clrMapOvr>
-    <a:masterClrMapping/>
-  </p:clrMapOvr>
-</p:sldLayout>
-</file>
-
-<file path=ppt/slideLayouts/slideLayout6.xml><?xml version="1.0" encoding="utf-8"?>
-<p:sldLayout xmlns:a="http://schemas.openxmlformats.org/drawingml/2006/main" xmlns:r="http://schemas.openxmlformats.org/officeDocument/2006/relationships" xmlns:p="http://schemas.openxmlformats.org/presentationml/2006/main" type="twoObj" preserve="1">
-  <p:cSld name="Two Content">
-    <p:spTree>
-      <p:nvGrpSpPr>
-        <p:cNvPr id="1" name=""/>
-        <p:cNvGrpSpPr/>
-        <p:nvPr/>
-      </p:nvGrpSpPr>
-      <p:grpSpPr>
-        <a:xfrm>
-          <a:off x="0" y="0"/>
-          <a:ext cx="0" cy="0"/>
-          <a:chOff x="0" y="0"/>
-          <a:chExt cx="0" cy="0"/>
-        </a:xfrm>
-      </p:grpSpPr>
-      <p:sp>
-        <p:nvSpPr>
-          <p:cNvPr id="2" name="Title 1"/>
-          <p:cNvSpPr>
-            <a:spLocks noGrp="1"/>
-          </p:cNvSpPr>
-          <p:nvPr>
-            <p:ph type="title"/>
-          </p:nvPr>
-        </p:nvSpPr>
-        <p:spPr>
-          <a:xfrm>
-            <a:off x="381000" y="0"/>
-            <a:ext cx="9906000" cy="457200"/>
-          </a:xfrm>
-          <a:prstGeom prst="rect">
-            <a:avLst/>
-          </a:prstGeom>
-        </p:spPr>
-        <p:txBody>
-          <a:bodyPr/>
-          <a:lstStyle>
-            <a:lvl1pPr>
-              <a:defRPr baseline="0">
-                <a:solidFill>
-                  <a:schemeClr val="tx1"/>
-                </a:solidFill>
-              </a:defRPr>
-            </a:lvl1pPr>
-          </a:lstStyle>
-          <a:p>
-            <a:r>
-              <a:rPr lang="en-US" dirty="0"/>
-              <a:t>Click to edit Master title style</a:t>
-            </a:r>
-          </a:p>
-        </p:txBody>
-      </p:sp>
-      <p:sp>
-        <p:nvSpPr>
-          <p:cNvPr id="3" name="Content Placeholder 2"/>
-          <p:cNvSpPr>
-            <a:spLocks noGrp="1"/>
-          </p:cNvSpPr>
-          <p:nvPr>
-            <p:ph sz="half" idx="1"/>
-          </p:nvPr>
-        </p:nvSpPr>
-        <p:spPr>
-          <a:xfrm>
-            <a:off x="320040" y="571500"/>
-            <a:ext cx="5715000" cy="5715000"/>
-          </a:xfrm>
-          <a:prstGeom prst="rect">
-            <a:avLst/>
-          </a:prstGeom>
-        </p:spPr>
-        <p:txBody>
-          <a:bodyPr/>
-          <a:lstStyle>
-            <a:lvl1pPr>
-              <a:buNone/>
-              <a:defRPr sz="2800"/>
-            </a:lvl1pPr>
-            <a:lvl2pPr marL="457200" indent="-228600">
-              <a:buFont typeface="Arial" panose="020B0604020202020204" pitchFamily="34" charset="0"/>
-              <a:buChar char="•"/>
-              <a:defRPr sz="2400"/>
-            </a:lvl2pPr>
-            <a:lvl3pPr marL="914400" indent="-228600">
-              <a:buFont typeface="Wingdings" pitchFamily="2" charset="2"/>
-              <a:buChar char="§"/>
-              <a:defRPr sz="2000"/>
-            </a:lvl3pPr>
-            <a:lvl4pPr marL="1371600" indent="-228600">
-              <a:defRPr sz="1800"/>
-            </a:lvl4pPr>
-            <a:lvl5pPr marL="1600200" indent="-228600">
-              <a:defRPr sz="1800"/>
-            </a:lvl5pPr>
-            <a:lvl6pPr>
-              <a:defRPr sz="1800"/>
-            </a:lvl6pPr>
-            <a:lvl7pPr>
-              <a:defRPr sz="1800"/>
-            </a:lvl7pPr>
-            <a:lvl8pPr>
-              <a:defRPr sz="1800"/>
-            </a:lvl8pPr>
-            <a:lvl9pPr>
-              <a:defRPr sz="1800"/>
-            </a:lvl9pPr>
-          </a:lstStyle>
-          <a:p>
-            <a:pPr lvl="0"/>
-            <a:r>
-              <a:rPr lang="en-US" dirty="0"/>
-              <a:t>Click to edit Master text styles</a:t>
-            </a:r>
-          </a:p>
-          <a:p>
-            <a:pPr lvl="1"/>
-            <a:r>
-              <a:rPr lang="en-US" dirty="0"/>
-              <a:t>Second level</a:t>
-            </a:r>
-          </a:p>
-          <a:p>
-            <a:pPr lvl="2"/>
-            <a:r>
-              <a:rPr lang="en-US" dirty="0"/>
-              <a:t>Third level</a:t>
-            </a:r>
-          </a:p>
-          <a:p>
-            <a:pPr lvl="3"/>
-            <a:r>
-              <a:rPr lang="en-US" dirty="0"/>
-              <a:t>Fourth level</a:t>
-            </a:r>
-          </a:p>
-          <a:p>
-            <a:pPr lvl="4"/>
-            <a:r>
-              <a:rPr lang="en-US" dirty="0"/>
-              <a:t>Fifth level</a:t>
-            </a:r>
-          </a:p>
-        </p:txBody>
-      </p:sp>
-      <p:sp>
-        <p:nvSpPr>
-          <p:cNvPr id="4" name="Content Placeholder 3"/>
-          <p:cNvSpPr>
-            <a:spLocks noGrp="1"/>
-          </p:cNvSpPr>
-          <p:nvPr>
-            <p:ph sz="half" idx="2"/>
-          </p:nvPr>
-        </p:nvSpPr>
-        <p:spPr>
-          <a:xfrm>
-            <a:off x="6197600" y="571500"/>
-            <a:ext cx="5715000" cy="5715000"/>
-          </a:xfrm>
-          <a:prstGeom prst="rect">
-            <a:avLst/>
-          </a:prstGeom>
-        </p:spPr>
-        <p:txBody>
-          <a:bodyPr/>
-          <a:lstStyle>
-            <a:lvl1pPr>
-              <a:buNone/>
-              <a:defRPr sz="2800"/>
-            </a:lvl1pPr>
-            <a:lvl2pPr marL="457200" indent="-228600">
-              <a:buFont typeface="Arial" panose="020B0604020202020204" pitchFamily="34" charset="0"/>
-              <a:buChar char="•"/>
-              <a:defRPr sz="2400"/>
-            </a:lvl2pPr>
-            <a:lvl3pPr marL="914400" indent="-228600">
-              <a:buFont typeface="Wingdings" pitchFamily="2" charset="2"/>
-              <a:buChar char="§"/>
-              <a:defRPr sz="2000"/>
-            </a:lvl3pPr>
-            <a:lvl4pPr marL="1371600" indent="-228600">
-              <a:defRPr sz="1800"/>
-            </a:lvl4pPr>
-            <a:lvl5pPr marL="1600200" indent="-228600">
-              <a:defRPr sz="1800"/>
-            </a:lvl5pPr>
-            <a:lvl6pPr>
-              <a:defRPr sz="1800"/>
-            </a:lvl6pPr>
-            <a:lvl7pPr>
-              <a:defRPr sz="1800"/>
-            </a:lvl7pPr>
-            <a:lvl8pPr>
-              <a:defRPr sz="1800"/>
-            </a:lvl8pPr>
-            <a:lvl9pPr>
-              <a:defRPr sz="1800"/>
-            </a:lvl9pPr>
-          </a:lstStyle>
-          <a:p>
-            <a:pPr lvl="0"/>
-            <a:r>
-              <a:rPr lang="en-US" dirty="0"/>
-              <a:t>Click to edit Master text styles</a:t>
-            </a:r>
-          </a:p>
-          <a:p>
-            <a:pPr lvl="1"/>
-            <a:r>
-              <a:rPr lang="en-US" dirty="0"/>
-              <a:t>Second level</a:t>
-            </a:r>
-          </a:p>
-          <a:p>
-            <a:pPr lvl="2"/>
-            <a:r>
-              <a:rPr lang="en-US" dirty="0"/>
-              <a:t>Third level</a:t>
-            </a:r>
-          </a:p>
-          <a:p>
-            <a:pPr lvl="3"/>
-            <a:r>
-              <a:rPr lang="en-US" dirty="0"/>
-              <a:t>Fourth level</a:t>
-            </a:r>
-          </a:p>
-          <a:p>
-            <a:pPr lvl="4"/>
-            <a:r>
-              <a:rPr lang="en-US" dirty="0"/>
-              <a:t>Fifth level</a:t>
-            </a:r>
-          </a:p>
-        </p:txBody>
-      </p:sp>
-      <p:sp>
-        <p:nvSpPr>
-          <p:cNvPr id="6" name="Slide Number Placeholder 5">
-            <a:extLst>
-              <a:ext uri="{FF2B5EF4-FFF2-40B4-BE49-F238E27FC236}">
-                <a16:creationId xmlns:a16="http://schemas.microsoft.com/office/drawing/2014/main" id="{70FEC3C9-9B7B-D61A-73C1-617F8C241600}"/>
-              </a:ext>
-            </a:extLst>
-          </p:cNvPr>
-          <p:cNvSpPr txBox="1">
-            <a:spLocks/>
-          </p:cNvSpPr>
-          <p:nvPr userDrawn="1"/>
-        </p:nvSpPr>
-        <p:spPr>
-          <a:xfrm>
-            <a:off x="13014" y="6481724"/>
-            <a:ext cx="477640" cy="365125"/>
-          </a:xfrm>
-          <a:prstGeom prst="rect">
-            <a:avLst/>
-          </a:prstGeom>
-        </p:spPr>
-        <p:txBody>
-          <a:bodyPr vert="horz" lIns="91440" tIns="45720" rIns="91440" bIns="45720" rtlCol="0" anchor="ctr"/>
-          <a:lstStyle>
-            <a:defPPr>
-              <a:defRPr lang="en-US"/>
-            </a:defPPr>
-            <a:lvl1pPr marL="0" algn="ctr" defTabSz="609585" rtl="0" eaLnBrk="1" latinLnBrk="0" hangingPunct="1">
-              <a:defRPr sz="1200" kern="1200" baseline="0">
-                <a:solidFill>
-                  <a:schemeClr val="tx1"/>
-                </a:solidFill>
-                <a:latin typeface="+mn-lt"/>
-                <a:ea typeface="+mn-ea"/>
-                <a:cs typeface="+mn-cs"/>
-              </a:defRPr>
-            </a:lvl1pPr>
-            <a:lvl2pPr marL="609585" algn="l" defTabSz="609585" rtl="0" eaLnBrk="1" latinLnBrk="0" hangingPunct="1">
-              <a:defRPr sz="2400" kern="1200">
-                <a:solidFill>
-                  <a:schemeClr val="tx1"/>
-                </a:solidFill>
-                <a:latin typeface="+mn-lt"/>
-                <a:ea typeface="+mn-ea"/>
-                <a:cs typeface="+mn-cs"/>
-              </a:defRPr>
-            </a:lvl2pPr>
-            <a:lvl3pPr marL="1219170" algn="l" defTabSz="609585" rtl="0" eaLnBrk="1" latinLnBrk="0" hangingPunct="1">
-              <a:defRPr sz="2400" kern="1200">
-                <a:solidFill>
-                  <a:schemeClr val="tx1"/>
-                </a:solidFill>
-                <a:latin typeface="+mn-lt"/>
-                <a:ea typeface="+mn-ea"/>
-                <a:cs typeface="+mn-cs"/>
-              </a:defRPr>
-            </a:lvl3pPr>
-            <a:lvl4pPr marL="1828754" algn="l" defTabSz="609585" rtl="0" eaLnBrk="1" latinLnBrk="0" hangingPunct="1">
-              <a:defRPr sz="2400" kern="1200">
-                <a:solidFill>
-                  <a:schemeClr val="tx1"/>
-                </a:solidFill>
-                <a:latin typeface="+mn-lt"/>
-                <a:ea typeface="+mn-ea"/>
-                <a:cs typeface="+mn-cs"/>
-              </a:defRPr>
-            </a:lvl4pPr>
-            <a:lvl5pPr marL="2438339" algn="l" defTabSz="609585" rtl="0" eaLnBrk="1" latinLnBrk="0" hangingPunct="1">
-              <a:defRPr sz="2400" kern="1200">
-                <a:solidFill>
-                  <a:schemeClr val="tx1"/>
-                </a:solidFill>
-                <a:latin typeface="+mn-lt"/>
-                <a:ea typeface="+mn-ea"/>
-                <a:cs typeface="+mn-cs"/>
-              </a:defRPr>
-            </a:lvl5pPr>
-            <a:lvl6pPr marL="3047924" algn="l" defTabSz="609585" rtl="0" eaLnBrk="1" latinLnBrk="0" hangingPunct="1">
-              <a:defRPr sz="2400" kern="1200">
-                <a:solidFill>
-                  <a:schemeClr val="tx1"/>
-                </a:solidFill>
-                <a:latin typeface="+mn-lt"/>
-                <a:ea typeface="+mn-ea"/>
-                <a:cs typeface="+mn-cs"/>
-              </a:defRPr>
-            </a:lvl6pPr>
-            <a:lvl7pPr marL="3657509" algn="l" defTabSz="609585" rtl="0" eaLnBrk="1" latinLnBrk="0" hangingPunct="1">
-              <a:defRPr sz="2400" kern="1200">
-                <a:solidFill>
-                  <a:schemeClr val="tx1"/>
-                </a:solidFill>
-                <a:latin typeface="+mn-lt"/>
-                <a:ea typeface="+mn-ea"/>
-                <a:cs typeface="+mn-cs"/>
-              </a:defRPr>
-            </a:lvl7pPr>
-            <a:lvl8pPr marL="4267093" algn="l" defTabSz="609585" rtl="0" eaLnBrk="1" latinLnBrk="0" hangingPunct="1">
-              <a:defRPr sz="2400" kern="1200">
-                <a:solidFill>
-                  <a:schemeClr val="tx1"/>
-                </a:solidFill>
-                <a:latin typeface="+mn-lt"/>
-                <a:ea typeface="+mn-ea"/>
-                <a:cs typeface="+mn-cs"/>
-              </a:defRPr>
-            </a:lvl8pPr>
-            <a:lvl9pPr marL="4876678" algn="l" defTabSz="609585" rtl="0" eaLnBrk="1" latinLnBrk="0" hangingPunct="1">
-              <a:defRPr sz="2400" kern="1200">
-                <a:solidFill>
-                  <a:schemeClr val="tx1"/>
-                </a:solidFill>
-                <a:latin typeface="+mn-lt"/>
-                <a:ea typeface="+mn-ea"/>
-                <a:cs typeface="+mn-cs"/>
-              </a:defRPr>
-            </a:lvl9pPr>
-          </a:lstStyle>
-          <a:p>
-            <a:fld id="{C5EF2332-01BF-834F-8236-50238282D533}" type="slidenum">
-              <a:rPr lang="en-US" smtClean="0"/>
-              <a:pPr/>
-              <a:t>‹#›</a:t>
-            </a:fld>
-            <a:endParaRPr lang="en-US" dirty="0"/>
-          </a:p>
-        </p:txBody>
-      </p:sp>
-    </p:spTree>
-    <p:extLst>
-      <p:ext uri="{BB962C8B-B14F-4D97-AF65-F5344CB8AC3E}">
-        <p14:creationId xmlns:p14="http://schemas.microsoft.com/office/powerpoint/2010/main" val="2619886245"/>
-      </p:ext>
-    </p:extLst>
-  </p:cSld>
-  <p:clrMapOvr>
-    <a:masterClrMapping/>
-  </p:clrMapOvr>
-</p:sldLayout>
-</file>
-
-<file path=ppt/slideLayouts/slideLayout7.xml><?xml version="1.0" encoding="utf-8"?>
-<p:sldLayout xmlns:a="http://schemas.openxmlformats.org/drawingml/2006/main" xmlns:r="http://schemas.openxmlformats.org/officeDocument/2006/relationships" xmlns:p="http://schemas.openxmlformats.org/presentationml/2006/main" preserve="1" userDrawn="1">
-  <p:cSld name="Comparison">
-    <p:spTree>
-      <p:nvGrpSpPr>
-        <p:cNvPr id="1" name=""/>
-        <p:cNvGrpSpPr/>
-        <p:nvPr/>
-      </p:nvGrpSpPr>
-      <p:grpSpPr>
-        <a:xfrm>
-          <a:off x="0" y="0"/>
-          <a:ext cx="0" cy="0"/>
-          <a:chOff x="0" y="0"/>
-          <a:chExt cx="0" cy="0"/>
-        </a:xfrm>
-      </p:grpSpPr>
-      <p:sp>
-        <p:nvSpPr>
-          <p:cNvPr id="2" name="Title 1"/>
-          <p:cNvSpPr>
-            <a:spLocks noGrp="1"/>
-          </p:cNvSpPr>
-          <p:nvPr>
-            <p:ph type="title"/>
-          </p:nvPr>
-        </p:nvSpPr>
-        <p:spPr>
-          <a:xfrm>
-            <a:off x="381000" y="0"/>
-            <a:ext cx="9906000" cy="457200"/>
-          </a:xfrm>
-          <a:prstGeom prst="rect">
-            <a:avLst/>
-          </a:prstGeom>
-        </p:spPr>
-        <p:txBody>
-          <a:bodyPr/>
-          <a:lstStyle>
-            <a:lvl1pPr>
-              <a:defRPr/>
-            </a:lvl1pPr>
-          </a:lstStyle>
-          <a:p>
-            <a:r>
-              <a:rPr lang="en-US" dirty="0"/>
-              <a:t>Click to edit Master title style</a:t>
-            </a:r>
-          </a:p>
-        </p:txBody>
-      </p:sp>
-      <p:sp>
-        <p:nvSpPr>
-          <p:cNvPr id="3" name="Text Placeholder 2"/>
-          <p:cNvSpPr>
-            <a:spLocks noGrp="1"/>
-          </p:cNvSpPr>
-          <p:nvPr>
-            <p:ph type="body" idx="1"/>
-          </p:nvPr>
-        </p:nvSpPr>
-        <p:spPr>
-          <a:xfrm>
-            <a:off x="320040" y="612147"/>
-            <a:ext cx="5715000" cy="639763"/>
-          </a:xfrm>
-          <a:prstGeom prst="rect">
-            <a:avLst/>
-          </a:prstGeom>
-        </p:spPr>
-        <p:txBody>
-          <a:bodyPr anchor="b"/>
-          <a:lstStyle>
-            <a:lvl1pPr marL="0" indent="0" algn="ctr">
-              <a:buNone/>
-              <a:defRPr sz="2400" b="1"/>
-            </a:lvl1pPr>
-            <a:lvl2pPr marL="457189" indent="0">
-              <a:buNone/>
-              <a:defRPr sz="2000" b="1"/>
-            </a:lvl2pPr>
-            <a:lvl3pPr marL="914377" indent="0">
-              <a:buNone/>
-              <a:defRPr sz="1800" b="1"/>
-            </a:lvl3pPr>
-            <a:lvl4pPr marL="1371566" indent="0">
-              <a:buNone/>
-              <a:defRPr sz="1600" b="1"/>
-            </a:lvl4pPr>
-            <a:lvl5pPr marL="1828754" indent="0">
-              <a:buNone/>
-              <a:defRPr sz="1600" b="1"/>
-            </a:lvl5pPr>
-            <a:lvl6pPr marL="2285943" indent="0">
-              <a:buNone/>
-              <a:defRPr sz="1600" b="1"/>
-            </a:lvl6pPr>
-            <a:lvl7pPr marL="2743131" indent="0">
-              <a:buNone/>
-              <a:defRPr sz="1600" b="1"/>
-            </a:lvl7pPr>
-            <a:lvl8pPr marL="3200320" indent="0">
-              <a:buNone/>
-              <a:defRPr sz="1600" b="1"/>
-            </a:lvl8pPr>
-            <a:lvl9pPr marL="3657509" indent="0">
-              <a:buNone/>
-              <a:defRPr sz="1600" b="1"/>
-            </a:lvl9pPr>
-          </a:lstStyle>
-          <a:p>
-            <a:pPr lvl="0"/>
-            <a:r>
-              <a:rPr lang="en-US" dirty="0"/>
-              <a:t>Click to edit Master text styles</a:t>
-            </a:r>
-          </a:p>
-        </p:txBody>
-      </p:sp>
-      <p:sp>
-        <p:nvSpPr>
-          <p:cNvPr id="5" name="Text Placeholder 4"/>
-          <p:cNvSpPr>
-            <a:spLocks noGrp="1"/>
-          </p:cNvSpPr>
-          <p:nvPr>
-            <p:ph type="body" sz="quarter" idx="3"/>
-          </p:nvPr>
-        </p:nvSpPr>
-        <p:spPr>
-          <a:xfrm>
-            <a:off x="6126480" y="612147"/>
-            <a:ext cx="5715000" cy="639763"/>
-          </a:xfrm>
-          <a:prstGeom prst="rect">
-            <a:avLst/>
-          </a:prstGeom>
-        </p:spPr>
-        <p:txBody>
-          <a:bodyPr anchor="b"/>
-          <a:lstStyle>
-            <a:lvl1pPr marL="0" indent="0" algn="ctr">
-              <a:buNone/>
-              <a:defRPr sz="2400" b="1"/>
-            </a:lvl1pPr>
-            <a:lvl2pPr marL="457189" indent="0">
-              <a:buNone/>
-              <a:defRPr sz="2000" b="1"/>
-            </a:lvl2pPr>
-            <a:lvl3pPr marL="914377" indent="0">
-              <a:buNone/>
-              <a:defRPr sz="1800" b="1"/>
-            </a:lvl3pPr>
-            <a:lvl4pPr marL="1371566" indent="0">
-              <a:buNone/>
-              <a:defRPr sz="1600" b="1"/>
-            </a:lvl4pPr>
-            <a:lvl5pPr marL="1828754" indent="0">
-              <a:buNone/>
-              <a:defRPr sz="1600" b="1"/>
-            </a:lvl5pPr>
-            <a:lvl6pPr marL="2285943" indent="0">
-              <a:buNone/>
-              <a:defRPr sz="1600" b="1"/>
-            </a:lvl6pPr>
-            <a:lvl7pPr marL="2743131" indent="0">
-              <a:buNone/>
-              <a:defRPr sz="1600" b="1"/>
-            </a:lvl7pPr>
-            <a:lvl8pPr marL="3200320" indent="0">
-              <a:buNone/>
-              <a:defRPr sz="1600" b="1"/>
-            </a:lvl8pPr>
-            <a:lvl9pPr marL="3657509" indent="0">
-              <a:buNone/>
-              <a:defRPr sz="1600" b="1"/>
-            </a:lvl9pPr>
-          </a:lstStyle>
-          <a:p>
-            <a:pPr lvl="0"/>
-            <a:r>
-              <a:rPr lang="en-US" dirty="0"/>
-              <a:t>Click to edit Master text styles</a:t>
-            </a:r>
-          </a:p>
-        </p:txBody>
-      </p:sp>
-      <p:sp>
-        <p:nvSpPr>
-          <p:cNvPr id="8" name="Slide Number Placeholder 5">
-            <a:extLst>
-              <a:ext uri="{FF2B5EF4-FFF2-40B4-BE49-F238E27FC236}">
-                <a16:creationId xmlns:a16="http://schemas.microsoft.com/office/drawing/2014/main" id="{C30DE9D8-BF0A-6CD3-1373-CA0B438EB45A}"/>
-              </a:ext>
-            </a:extLst>
-          </p:cNvPr>
-          <p:cNvSpPr>
-            <a:spLocks noGrp="1"/>
-          </p:cNvSpPr>
-          <p:nvPr>
-            <p:ph type="sldNum" sz="quarter" idx="10"/>
-          </p:nvPr>
-        </p:nvSpPr>
-        <p:spPr>
-          <a:xfrm>
-            <a:off x="13014" y="6481724"/>
-            <a:ext cx="477640" cy="365125"/>
-          </a:xfrm>
-          <a:prstGeom prst="rect">
-            <a:avLst/>
-          </a:prstGeom>
-        </p:spPr>
-        <p:txBody>
-          <a:bodyPr vert="horz" lIns="91440" tIns="45720" rIns="91440" bIns="45720" rtlCol="0" anchor="ctr"/>
-          <a:lstStyle>
-            <a:lvl1pPr algn="ctr">
-              <a:defRPr sz="1200" baseline="0">
-                <a:solidFill>
-                  <a:schemeClr val="tx1"/>
-                </a:solidFill>
-              </a:defRPr>
-            </a:lvl1pPr>
-          </a:lstStyle>
-          <a:p>
-            <a:fld id="{C5EF2332-01BF-834F-8236-50238282D533}" type="slidenum">
-              <a:rPr lang="en-US" smtClean="0"/>
-              <a:pPr/>
-              <a:t>‹#›</a:t>
-            </a:fld>
-            <a:endParaRPr lang="en-US" dirty="0">
-              <a:solidFill>
-                <a:schemeClr val="tx1"/>
-              </a:solidFill>
-            </a:endParaRPr>
-          </a:p>
-        </p:txBody>
-      </p:sp>
-      <p:sp>
-        <p:nvSpPr>
-          <p:cNvPr id="10" name="Content Placeholder 2">
-            <a:extLst>
-              <a:ext uri="{FF2B5EF4-FFF2-40B4-BE49-F238E27FC236}">
-                <a16:creationId xmlns:a16="http://schemas.microsoft.com/office/drawing/2014/main" id="{E42C53FE-9BBD-5288-0E88-05B370AA1256}"/>
-              </a:ext>
-            </a:extLst>
-          </p:cNvPr>
-          <p:cNvSpPr>
-            <a:spLocks noGrp="1"/>
-          </p:cNvSpPr>
-          <p:nvPr>
-            <p:ph sz="half" idx="11"/>
-          </p:nvPr>
-        </p:nvSpPr>
-        <p:spPr>
-          <a:xfrm>
-            <a:off x="320040" y="1327868"/>
-            <a:ext cx="5715000" cy="4958632"/>
-          </a:xfrm>
-          <a:prstGeom prst="rect">
-            <a:avLst/>
-          </a:prstGeom>
-        </p:spPr>
-        <p:txBody>
-          <a:bodyPr/>
-          <a:lstStyle>
-            <a:lvl1pPr>
-              <a:buNone/>
-              <a:defRPr sz="2800"/>
-            </a:lvl1pPr>
-            <a:lvl2pPr marL="457200" indent="-228600">
-              <a:buFont typeface="Arial" panose="020B0604020202020204" pitchFamily="34" charset="0"/>
-              <a:buChar char="•"/>
-              <a:defRPr sz="2400"/>
-            </a:lvl2pPr>
-            <a:lvl3pPr marL="914400" indent="-228600">
-              <a:buFont typeface="Wingdings" pitchFamily="2" charset="2"/>
-              <a:buChar char="§"/>
-              <a:defRPr sz="2000"/>
-            </a:lvl3pPr>
-            <a:lvl4pPr marL="1371600" indent="-228600">
-              <a:defRPr sz="1800"/>
-            </a:lvl4pPr>
-            <a:lvl5pPr marL="1600200" indent="-228600">
-              <a:defRPr sz="1800"/>
-            </a:lvl5pPr>
-            <a:lvl6pPr>
-              <a:defRPr sz="1800"/>
-            </a:lvl6pPr>
-            <a:lvl7pPr>
-              <a:defRPr sz="1800"/>
-            </a:lvl7pPr>
-            <a:lvl8pPr>
-              <a:defRPr sz="1800"/>
-            </a:lvl8pPr>
-            <a:lvl9pPr>
-              <a:defRPr sz="1800"/>
-            </a:lvl9pPr>
-          </a:lstStyle>
-          <a:p>
-            <a:pPr lvl="0"/>
-            <a:r>
-              <a:rPr lang="en-US" dirty="0"/>
-              <a:t>Click to edit Master text styles</a:t>
-            </a:r>
-          </a:p>
-          <a:p>
-            <a:pPr lvl="1"/>
-            <a:r>
-              <a:rPr lang="en-US" dirty="0"/>
-              <a:t>Second level</a:t>
-            </a:r>
-          </a:p>
-          <a:p>
-            <a:pPr lvl="2"/>
-            <a:r>
-              <a:rPr lang="en-US" dirty="0"/>
-              <a:t>Third level</a:t>
-            </a:r>
-          </a:p>
-          <a:p>
-            <a:pPr lvl="3"/>
-            <a:r>
-              <a:rPr lang="en-US" dirty="0"/>
-              <a:t>Fourth level</a:t>
-            </a:r>
-          </a:p>
-          <a:p>
-            <a:pPr lvl="4"/>
-            <a:r>
-              <a:rPr lang="en-US" dirty="0"/>
-              <a:t>Fifth level</a:t>
-            </a:r>
-          </a:p>
-        </p:txBody>
-      </p:sp>
-      <p:sp>
-        <p:nvSpPr>
-          <p:cNvPr id="11" name="Content Placeholder 3">
-            <a:extLst>
-              <a:ext uri="{FF2B5EF4-FFF2-40B4-BE49-F238E27FC236}">
-                <a16:creationId xmlns:a16="http://schemas.microsoft.com/office/drawing/2014/main" id="{EC667219-84D4-DAC6-11DF-4C9DA2BDB985}"/>
-              </a:ext>
-            </a:extLst>
-          </p:cNvPr>
-          <p:cNvSpPr>
-            <a:spLocks noGrp="1"/>
-          </p:cNvSpPr>
-          <p:nvPr>
-            <p:ph sz="half" idx="2"/>
-          </p:nvPr>
-        </p:nvSpPr>
-        <p:spPr>
-          <a:xfrm>
-            <a:off x="6126480" y="1327868"/>
-            <a:ext cx="5715000" cy="4958632"/>
-          </a:xfrm>
-          <a:prstGeom prst="rect">
-            <a:avLst/>
-          </a:prstGeom>
-        </p:spPr>
-        <p:txBody>
-          <a:bodyPr/>
-          <a:lstStyle>
-            <a:lvl1pPr>
-              <a:buNone/>
-              <a:defRPr sz="2800"/>
-            </a:lvl1pPr>
-            <a:lvl2pPr marL="457200" indent="-228600">
-              <a:buFont typeface="Arial" panose="020B0604020202020204" pitchFamily="34" charset="0"/>
-              <a:buChar char="•"/>
-              <a:defRPr sz="2400"/>
-            </a:lvl2pPr>
-            <a:lvl3pPr marL="914400" indent="-228600">
-              <a:buFont typeface="Wingdings" pitchFamily="2" charset="2"/>
-              <a:buChar char="§"/>
-              <a:defRPr sz="2000"/>
-            </a:lvl3pPr>
-            <a:lvl4pPr marL="1371600" indent="-228600">
-              <a:defRPr sz="1800"/>
-            </a:lvl4pPr>
-            <a:lvl5pPr marL="1600200" indent="-228600">
-              <a:defRPr sz="1800"/>
-            </a:lvl5pPr>
-            <a:lvl6pPr>
-              <a:defRPr sz="1800"/>
-            </a:lvl6pPr>
-            <a:lvl7pPr>
-              <a:defRPr sz="1800"/>
-            </a:lvl7pPr>
-            <a:lvl8pPr>
-              <a:defRPr sz="1800"/>
-            </a:lvl8pPr>
-            <a:lvl9pPr>
-              <a:defRPr sz="1800"/>
-            </a:lvl9pPr>
-          </a:lstStyle>
-          <a:p>
-            <a:pPr lvl="0"/>
-            <a:r>
-              <a:rPr lang="en-US" dirty="0"/>
-              <a:t>Click to edit Master text styles</a:t>
-            </a:r>
-          </a:p>
-          <a:p>
-            <a:pPr lvl="1"/>
-            <a:r>
-              <a:rPr lang="en-US" dirty="0"/>
-              <a:t>Second level</a:t>
-            </a:r>
-          </a:p>
-          <a:p>
-            <a:pPr lvl="2"/>
-            <a:r>
-              <a:rPr lang="en-US" dirty="0"/>
-              <a:t>Third level</a:t>
-            </a:r>
-          </a:p>
-          <a:p>
-            <a:pPr lvl="3"/>
-            <a:r>
-              <a:rPr lang="en-US" dirty="0"/>
-              <a:t>Fourth level</a:t>
-            </a:r>
-          </a:p>
-          <a:p>
-            <a:pPr lvl="4"/>
-            <a:r>
-              <a:rPr lang="en-US" dirty="0"/>
-              <a:t>Fifth level</a:t>
-            </a:r>
-          </a:p>
-        </p:txBody>
-      </p:sp>
-    </p:spTree>
-    <p:extLst>
-      <p:ext uri="{BB962C8B-B14F-4D97-AF65-F5344CB8AC3E}">
-        <p14:creationId xmlns:p14="http://schemas.microsoft.com/office/powerpoint/2010/main" val="2535793967"/>
-      </p:ext>
-    </p:extLst>
-  </p:cSld>
-  <p:clrMapOvr>
-    <a:masterClrMapping/>
-  </p:clrMapOvr>
-</p:sldLayout>
-</file>
-
-<file path=ppt/slideLayouts/slideLayout8.xml><?xml version="1.0" encoding="utf-8"?>
-<p:sldLayout xmlns:a="http://schemas.openxmlformats.org/drawingml/2006/main" xmlns:r="http://schemas.openxmlformats.org/officeDocument/2006/relationships" xmlns:p="http://schemas.openxmlformats.org/presentationml/2006/main" type="titleOnly" preserve="1">
-  <p:cSld name="Title Only">
-    <p:spTree>
-      <p:nvGrpSpPr>
-        <p:cNvPr id="1" name=""/>
-        <p:cNvGrpSpPr/>
-        <p:nvPr/>
-      </p:nvGrpSpPr>
-      <p:grpSpPr>
-        <a:xfrm>
-          <a:off x="0" y="0"/>
-          <a:ext cx="0" cy="0"/>
-          <a:chOff x="0" y="0"/>
-          <a:chExt cx="0" cy="0"/>
-        </a:xfrm>
-      </p:grpSpPr>
-      <p:sp>
-        <p:nvSpPr>
-          <p:cNvPr id="2" name="Title 1"/>
-          <p:cNvSpPr>
-            <a:spLocks noGrp="1"/>
-          </p:cNvSpPr>
-          <p:nvPr>
-            <p:ph type="title"/>
-          </p:nvPr>
-        </p:nvSpPr>
-        <p:spPr>
-          <a:xfrm>
-            <a:off x="381000" y="0"/>
-            <a:ext cx="9906000" cy="457200"/>
-          </a:xfrm>
-          <a:prstGeom prst="rect">
-            <a:avLst/>
-          </a:prstGeom>
-        </p:spPr>
-        <p:txBody>
-          <a:bodyPr/>
-          <a:lstStyle/>
-          <a:p>
-            <a:r>
-              <a:rPr lang="en-US"/>
-              <a:t>Click to edit Master title style</a:t>
-            </a:r>
-          </a:p>
-        </p:txBody>
-      </p:sp>
-      <p:sp>
-        <p:nvSpPr>
-          <p:cNvPr id="3" name="Slide Number Placeholder 5">
-            <a:extLst>
-              <a:ext uri="{FF2B5EF4-FFF2-40B4-BE49-F238E27FC236}">
-                <a16:creationId xmlns:a16="http://schemas.microsoft.com/office/drawing/2014/main" id="{DE55E6F4-F503-8139-B06C-594972EDCC66}"/>
-              </a:ext>
-            </a:extLst>
-          </p:cNvPr>
-          <p:cNvSpPr txBox="1">
-            <a:spLocks/>
-          </p:cNvSpPr>
-          <p:nvPr userDrawn="1"/>
-        </p:nvSpPr>
-        <p:spPr>
-          <a:xfrm>
-            <a:off x="13014" y="6481724"/>
-            <a:ext cx="477640" cy="365125"/>
-          </a:xfrm>
-          <a:prstGeom prst="rect">
-            <a:avLst/>
-          </a:prstGeom>
-        </p:spPr>
-        <p:txBody>
-          <a:bodyPr vert="horz" lIns="91440" tIns="45720" rIns="91440" bIns="45720" rtlCol="0" anchor="ctr"/>
-          <a:lstStyle>
-            <a:defPPr>
-              <a:defRPr lang="en-US"/>
-            </a:defPPr>
-            <a:lvl1pPr marL="0" algn="ctr" defTabSz="609585" rtl="0" eaLnBrk="1" latinLnBrk="0" hangingPunct="1">
-              <a:defRPr sz="1200" kern="1200" baseline="0">
-                <a:solidFill>
-                  <a:schemeClr val="tx1"/>
-                </a:solidFill>
-                <a:latin typeface="+mn-lt"/>
-                <a:ea typeface="+mn-ea"/>
-                <a:cs typeface="+mn-cs"/>
-              </a:defRPr>
-            </a:lvl1pPr>
-            <a:lvl2pPr marL="609585" algn="l" defTabSz="609585" rtl="0" eaLnBrk="1" latinLnBrk="0" hangingPunct="1">
-              <a:defRPr sz="2400" kern="1200">
-                <a:solidFill>
-                  <a:schemeClr val="tx1"/>
-                </a:solidFill>
-                <a:latin typeface="+mn-lt"/>
-                <a:ea typeface="+mn-ea"/>
-                <a:cs typeface="+mn-cs"/>
-              </a:defRPr>
-            </a:lvl2pPr>
-            <a:lvl3pPr marL="1219170" algn="l" defTabSz="609585" rtl="0" eaLnBrk="1" latinLnBrk="0" hangingPunct="1">
-              <a:defRPr sz="2400" kern="1200">
-                <a:solidFill>
-                  <a:schemeClr val="tx1"/>
-                </a:solidFill>
-                <a:latin typeface="+mn-lt"/>
-                <a:ea typeface="+mn-ea"/>
-                <a:cs typeface="+mn-cs"/>
-              </a:defRPr>
-            </a:lvl3pPr>
-            <a:lvl4pPr marL="1828754" algn="l" defTabSz="609585" rtl="0" eaLnBrk="1" latinLnBrk="0" hangingPunct="1">
-              <a:defRPr sz="2400" kern="1200">
-                <a:solidFill>
-                  <a:schemeClr val="tx1"/>
-                </a:solidFill>
-                <a:latin typeface="+mn-lt"/>
-                <a:ea typeface="+mn-ea"/>
-                <a:cs typeface="+mn-cs"/>
-              </a:defRPr>
-            </a:lvl4pPr>
-            <a:lvl5pPr marL="2438339" algn="l" defTabSz="609585" rtl="0" eaLnBrk="1" latinLnBrk="0" hangingPunct="1">
-              <a:defRPr sz="2400" kern="1200">
-                <a:solidFill>
-                  <a:schemeClr val="tx1"/>
-                </a:solidFill>
-                <a:latin typeface="+mn-lt"/>
-                <a:ea typeface="+mn-ea"/>
-                <a:cs typeface="+mn-cs"/>
-              </a:defRPr>
-            </a:lvl5pPr>
-            <a:lvl6pPr marL="3047924" algn="l" defTabSz="609585" rtl="0" eaLnBrk="1" latinLnBrk="0" hangingPunct="1">
-              <a:defRPr sz="2400" kern="1200">
-                <a:solidFill>
-                  <a:schemeClr val="tx1"/>
-                </a:solidFill>
-                <a:latin typeface="+mn-lt"/>
-                <a:ea typeface="+mn-ea"/>
-                <a:cs typeface="+mn-cs"/>
-              </a:defRPr>
-            </a:lvl6pPr>
-            <a:lvl7pPr marL="3657509" algn="l" defTabSz="609585" rtl="0" eaLnBrk="1" latinLnBrk="0" hangingPunct="1">
-              <a:defRPr sz="2400" kern="1200">
-                <a:solidFill>
-                  <a:schemeClr val="tx1"/>
-                </a:solidFill>
-                <a:latin typeface="+mn-lt"/>
-                <a:ea typeface="+mn-ea"/>
-                <a:cs typeface="+mn-cs"/>
-              </a:defRPr>
-            </a:lvl7pPr>
-            <a:lvl8pPr marL="4267093" algn="l" defTabSz="609585" rtl="0" eaLnBrk="1" latinLnBrk="0" hangingPunct="1">
-              <a:defRPr sz="2400" kern="1200">
-                <a:solidFill>
-                  <a:schemeClr val="tx1"/>
-                </a:solidFill>
-                <a:latin typeface="+mn-lt"/>
-                <a:ea typeface="+mn-ea"/>
-                <a:cs typeface="+mn-cs"/>
-              </a:defRPr>
-            </a:lvl8pPr>
-            <a:lvl9pPr marL="4876678" algn="l" defTabSz="609585" rtl="0" eaLnBrk="1" latinLnBrk="0" hangingPunct="1">
-              <a:defRPr sz="2400" kern="1200">
-                <a:solidFill>
-                  <a:schemeClr val="tx1"/>
-                </a:solidFill>
-                <a:latin typeface="+mn-lt"/>
-                <a:ea typeface="+mn-ea"/>
-                <a:cs typeface="+mn-cs"/>
-              </a:defRPr>
-            </a:lvl9pPr>
-          </a:lstStyle>
-          <a:p>
-            <a:fld id="{C5EF2332-01BF-834F-8236-50238282D533}" type="slidenum">
-              <a:rPr lang="en-US" smtClean="0"/>
-              <a:pPr/>
-              <a:t>‹#›</a:t>
-            </a:fld>
-            <a:endParaRPr lang="en-US" dirty="0"/>
-          </a:p>
-        </p:txBody>
-      </p:sp>
-    </p:spTree>
-    <p:extLst>
-      <p:ext uri="{BB962C8B-B14F-4D97-AF65-F5344CB8AC3E}">
-        <p14:creationId xmlns:p14="http://schemas.microsoft.com/office/powerpoint/2010/main" val="3472721253"/>
-      </p:ext>
-    </p:extLst>
-  </p:cSld>
-  <p:clrMapOvr>
-    <a:masterClrMapping/>
-  </p:clrMapOvr>
-</p:sldLayout>
-</file>
-
-<file path=ppt/slideLayouts/slideLayout9.xml><?xml version="1.0" encoding="utf-8"?>
-<p:sldLayout xmlns:a="http://schemas.openxmlformats.org/drawingml/2006/main" xmlns:r="http://schemas.openxmlformats.org/officeDocument/2006/relationships" xmlns:p="http://schemas.openxmlformats.org/presentationml/2006/main" type="blank" preserve="1">
-  <p:cSld name="Blank">
-    <p:spTree>
-      <p:nvGrpSpPr>
-        <p:cNvPr id="1" name=""/>
-        <p:cNvGrpSpPr/>
-        <p:nvPr/>
-      </p:nvGrpSpPr>
-      <p:grpSpPr>
-        <a:xfrm>
-          <a:off x="0" y="0"/>
-          <a:ext cx="0" cy="0"/>
-          <a:chOff x="0" y="0"/>
-          <a:chExt cx="0" cy="0"/>
-        </a:xfrm>
-      </p:grpSpPr>
-      <p:sp>
-        <p:nvSpPr>
-          <p:cNvPr id="2" name="Slide Number Placeholder 5">
-            <a:extLst>
-              <a:ext uri="{FF2B5EF4-FFF2-40B4-BE49-F238E27FC236}">
-                <a16:creationId xmlns:a16="http://schemas.microsoft.com/office/drawing/2014/main" id="{5BDF375F-21D8-91BD-460B-3AC2191F7253}"/>
-              </a:ext>
-            </a:extLst>
-          </p:cNvPr>
-          <p:cNvSpPr txBox="1">
-            <a:spLocks/>
-          </p:cNvSpPr>
-          <p:nvPr userDrawn="1"/>
-        </p:nvSpPr>
-        <p:spPr>
-          <a:xfrm>
-            <a:off x="13014" y="6481724"/>
-            <a:ext cx="477640" cy="365125"/>
-          </a:xfrm>
-          <a:prstGeom prst="rect">
-            <a:avLst/>
-          </a:prstGeom>
-        </p:spPr>
-        <p:txBody>
-          <a:bodyPr vert="horz" lIns="91440" tIns="45720" rIns="91440" bIns="45720" rtlCol="0" anchor="ctr"/>
-          <a:lstStyle>
-            <a:defPPr>
-              <a:defRPr lang="en-US"/>
-            </a:defPPr>
-            <a:lvl1pPr marL="0" algn="ctr" defTabSz="609585" rtl="0" eaLnBrk="1" latinLnBrk="0" hangingPunct="1">
-              <a:defRPr sz="1200" kern="1200" baseline="0">
-                <a:solidFill>
-                  <a:schemeClr val="tx1"/>
-                </a:solidFill>
-                <a:latin typeface="+mn-lt"/>
-                <a:ea typeface="+mn-ea"/>
-                <a:cs typeface="+mn-cs"/>
-              </a:defRPr>
-            </a:lvl1pPr>
-            <a:lvl2pPr marL="609585" algn="l" defTabSz="609585" rtl="0" eaLnBrk="1" latinLnBrk="0" hangingPunct="1">
-              <a:defRPr sz="2400" kern="1200">
-                <a:solidFill>
-                  <a:schemeClr val="tx1"/>
-                </a:solidFill>
-                <a:latin typeface="+mn-lt"/>
-                <a:ea typeface="+mn-ea"/>
-                <a:cs typeface="+mn-cs"/>
-              </a:defRPr>
-            </a:lvl2pPr>
-            <a:lvl3pPr marL="1219170" algn="l" defTabSz="609585" rtl="0" eaLnBrk="1" latinLnBrk="0" hangingPunct="1">
-              <a:defRPr sz="2400" kern="1200">
-                <a:solidFill>
-                  <a:schemeClr val="tx1"/>
-                </a:solidFill>
-                <a:latin typeface="+mn-lt"/>
-                <a:ea typeface="+mn-ea"/>
-                <a:cs typeface="+mn-cs"/>
-              </a:defRPr>
-            </a:lvl3pPr>
-            <a:lvl4pPr marL="1828754" algn="l" defTabSz="609585" rtl="0" eaLnBrk="1" latinLnBrk="0" hangingPunct="1">
-              <a:defRPr sz="2400" kern="1200">
-                <a:solidFill>
-                  <a:schemeClr val="tx1"/>
-                </a:solidFill>
-                <a:latin typeface="+mn-lt"/>
-                <a:ea typeface="+mn-ea"/>
-                <a:cs typeface="+mn-cs"/>
-              </a:defRPr>
-            </a:lvl4pPr>
-            <a:lvl5pPr marL="2438339" algn="l" defTabSz="609585" rtl="0" eaLnBrk="1" latinLnBrk="0" hangingPunct="1">
-              <a:defRPr sz="2400" kern="1200">
-                <a:solidFill>
-                  <a:schemeClr val="tx1"/>
-                </a:solidFill>
-                <a:latin typeface="+mn-lt"/>
-                <a:ea typeface="+mn-ea"/>
-                <a:cs typeface="+mn-cs"/>
-              </a:defRPr>
-            </a:lvl5pPr>
-            <a:lvl6pPr marL="3047924" algn="l" defTabSz="609585" rtl="0" eaLnBrk="1" latinLnBrk="0" hangingPunct="1">
-              <a:defRPr sz="2400" kern="1200">
-                <a:solidFill>
-                  <a:schemeClr val="tx1"/>
-                </a:solidFill>
-                <a:latin typeface="+mn-lt"/>
-                <a:ea typeface="+mn-ea"/>
-                <a:cs typeface="+mn-cs"/>
-              </a:defRPr>
-            </a:lvl6pPr>
-            <a:lvl7pPr marL="3657509" algn="l" defTabSz="609585" rtl="0" eaLnBrk="1" latinLnBrk="0" hangingPunct="1">
-              <a:defRPr sz="2400" kern="1200">
-                <a:solidFill>
-                  <a:schemeClr val="tx1"/>
-                </a:solidFill>
-                <a:latin typeface="+mn-lt"/>
-                <a:ea typeface="+mn-ea"/>
-                <a:cs typeface="+mn-cs"/>
-              </a:defRPr>
-            </a:lvl7pPr>
-            <a:lvl8pPr marL="4267093" algn="l" defTabSz="609585" rtl="0" eaLnBrk="1" latinLnBrk="0" hangingPunct="1">
-              <a:defRPr sz="2400" kern="1200">
-                <a:solidFill>
-                  <a:schemeClr val="tx1"/>
-                </a:solidFill>
-                <a:latin typeface="+mn-lt"/>
-                <a:ea typeface="+mn-ea"/>
-                <a:cs typeface="+mn-cs"/>
-              </a:defRPr>
-            </a:lvl8pPr>
-            <a:lvl9pPr marL="4876678" algn="l" defTabSz="609585" rtl="0" eaLnBrk="1" latinLnBrk="0" hangingPunct="1">
-              <a:defRPr sz="2400" kern="1200">
-                <a:solidFill>
-                  <a:schemeClr val="tx1"/>
-                </a:solidFill>
-                <a:latin typeface="+mn-lt"/>
-                <a:ea typeface="+mn-ea"/>
-                <a:cs typeface="+mn-cs"/>
-              </a:defRPr>
-            </a:lvl9pPr>
-          </a:lstStyle>
-          <a:p>
-            <a:fld id="{C5EF2332-01BF-834F-8236-50238282D533}" type="slidenum">
-              <a:rPr lang="en-US" smtClean="0"/>
-              <a:pPr/>
-              <a:t>‹#›</a:t>
-            </a:fld>
-            <a:endParaRPr lang="en-US" dirty="0"/>
-          </a:p>
-        </p:txBody>
-      </p:sp>
-    </p:spTree>
-    <p:extLst>
-      <p:ext uri="{BB962C8B-B14F-4D97-AF65-F5344CB8AC3E}">
-        <p14:creationId xmlns:p14="http://schemas.microsoft.com/office/powerpoint/2010/main" val="2130901097"/>
+        <p14:creationId xmlns:p14="http://schemas.microsoft.com/office/powerpoint/2010/main" val="3566899855"/>
       </p:ext>
     </p:extLst>
   </p:cSld>
@@ -3913,8 +4204,8 @@
         </p:nvSpPr>
         <p:spPr>
           <a:xfrm>
-            <a:off x="381000" y="571500"/>
-            <a:ext cx="11430000" cy="5715000"/>
+            <a:off x="381000" y="785190"/>
+            <a:ext cx="11430000" cy="5486400"/>
           </a:xfrm>
           <a:prstGeom prst="rect">
             <a:avLst/>
@@ -4061,7 +4352,7 @@
           <p:nvPr userDrawn="1"/>
         </p:nvPicPr>
         <p:blipFill>
-          <a:blip r:embed="rId13">
+          <a:blip r:embed="rId11">
             <a:alphaModFix/>
           </a:blip>
           <a:stretch>
@@ -4228,7 +4519,7 @@
           <p:nvPr userDrawn="1"/>
         </p:nvPicPr>
         <p:blipFill>
-          <a:blip r:embed="rId14"/>
+          <a:blip r:embed="rId12"/>
           <a:stretch>
             <a:fillRect/>
           </a:stretch>
@@ -4292,10 +4583,10 @@
       </p:sp>
       <p:sp>
         <p:nvSpPr>
-          <p:cNvPr id="7" name="Footer Placeholder 6">
+          <p:cNvPr id="4" name="Footer Placeholder 6">
             <a:extLst>
               <a:ext uri="{FF2B5EF4-FFF2-40B4-BE49-F238E27FC236}">
-                <a16:creationId xmlns:a16="http://schemas.microsoft.com/office/drawing/2014/main" id="{9502F667-8912-B21B-3216-B2EB150383C9}"/>
+                <a16:creationId xmlns:a16="http://schemas.microsoft.com/office/drawing/2014/main" id="{C3EDFC53-4628-443B-C420-419022E1866B}"/>
               </a:ext>
             </a:extLst>
           </p:cNvPr>
@@ -4342,16 +4633,14 @@
   <p:clrMap bg1="lt1" tx1="dk1" bg2="lt2" tx2="dk2" accent1="accent1" accent2="accent2" accent3="accent3" accent4="accent4" accent5="accent5" accent6="accent6" hlink="hlink" folHlink="folHlink"/>
   <p:sldLayoutIdLst>
     <p:sldLayoutId id="2147483658" r:id="rId1"/>
-    <p:sldLayoutId id="2147483671" r:id="rId2"/>
-    <p:sldLayoutId id="2147483672" r:id="rId3"/>
+    <p:sldLayoutId id="2147483654" r:id="rId2"/>
+    <p:sldLayoutId id="2147483671" r:id="rId3"/>
     <p:sldLayoutId id="2147483650" r:id="rId4"/>
     <p:sldLayoutId id="2147483651" r:id="rId5"/>
     <p:sldLayoutId id="2147483652" r:id="rId6"/>
     <p:sldLayoutId id="2147483653" r:id="rId7"/>
-    <p:sldLayoutId id="2147483654" r:id="rId8"/>
-    <p:sldLayoutId id="2147483655" r:id="rId9"/>
-    <p:sldLayoutId id="2147483656" r:id="rId10"/>
-    <p:sldLayoutId id="2147483657" r:id="rId11"/>
+    <p:sldLayoutId id="2147483656" r:id="rId8"/>
+    <p:sldLayoutId id="2147483657" r:id="rId9"/>
   </p:sldLayoutIdLst>
   <p:hf hdr="0" ftr="0"/>
   <p:txStyles>
@@ -4637,7 +4926,7 @@
             <a:spLocks noGrp="1"/>
           </p:cNvSpPr>
           <p:nvPr>
-            <p:ph type="sldNum" idx="12"/>
+            <p:ph type="sldNum" idx="4"/>
           </p:nvPr>
         </p:nvSpPr>
         <p:spPr>
@@ -4742,38 +5031,6 @@
             <a:noAutofit/>
           </a:bodyPr>
           <a:lstStyle/>
-          <a:p>
-            <a:pPr marL="0" lvl="0" indent="0" algn="l" rtl="0">
-              <a:spcBef>
-                <a:spcPts val="0"/>
-              </a:spcBef>
-              <a:spcAft>
-                <a:spcPts val="0"/>
-              </a:spcAft>
-              <a:buNone/>
-            </a:pPr>
-            <a:r>
-              <a:rPr lang="en" sz="1000" b="1" dirty="0">
-                <a:solidFill>
-                  <a:schemeClr val="dk1"/>
-                </a:solidFill>
-                <a:latin typeface="Poppins"/>
-                <a:ea typeface="Poppins"/>
-                <a:cs typeface="Poppins"/>
-                <a:sym typeface="Poppins"/>
-              </a:rPr>
-              <a:t>SEPTEMBER 15, 2025</a:t>
-            </a:r>
-            <a:endParaRPr sz="1000" b="1" dirty="0">
-              <a:solidFill>
-                <a:schemeClr val="dk1"/>
-              </a:solidFill>
-              <a:latin typeface="Poppins"/>
-              <a:ea typeface="Poppins"/>
-              <a:cs typeface="Poppins"/>
-              <a:sym typeface="Poppins"/>
-            </a:endParaRPr>
-          </a:p>
           <a:p>
             <a:pPr marL="0" lvl="0" indent="0" algn="l" rtl="0">
               <a:lnSpc>
@@ -4976,81 +5233,6 @@
               <a:t> labore</a:t>
             </a:r>
             <a:endParaRPr dirty="0">
-              <a:solidFill>
-                <a:schemeClr val="dk1"/>
-              </a:solidFill>
-              <a:latin typeface="Poppins"/>
-              <a:ea typeface="Poppins"/>
-              <a:cs typeface="Poppins"/>
-              <a:sym typeface="Poppins"/>
-            </a:endParaRPr>
-          </a:p>
-        </p:txBody>
-      </p:sp>
-      <p:sp>
-        <p:nvSpPr>
-          <p:cNvPr id="8" name="Google Shape;90;p13">
-            <a:extLst>
-              <a:ext uri="{FF2B5EF4-FFF2-40B4-BE49-F238E27FC236}">
-                <a16:creationId xmlns:a16="http://schemas.microsoft.com/office/drawing/2014/main" id="{B8B60B50-5E9E-9761-9B81-0541499C64DE}"/>
-              </a:ext>
-            </a:extLst>
-          </p:cNvPr>
-          <p:cNvSpPr txBox="1"/>
-          <p:nvPr/>
-        </p:nvSpPr>
-        <p:spPr>
-          <a:xfrm>
-            <a:off x="691024" y="6090236"/>
-            <a:ext cx="4483141" cy="366319"/>
-          </a:xfrm>
-          <a:prstGeom prst="rect">
-            <a:avLst/>
-          </a:prstGeom>
-          <a:noFill/>
-          <a:ln>
-            <a:noFill/>
-          </a:ln>
-        </p:spPr>
-        <p:txBody>
-          <a:bodyPr spcFirstLastPara="1" wrap="square" lIns="0" tIns="0" rIns="0" bIns="0" anchor="t" anchorCtr="0">
-            <a:noAutofit/>
-          </a:bodyPr>
-          <a:lstStyle/>
-          <a:p>
-            <a:pPr marL="0" lvl="0" indent="0" algn="l" rtl="0">
-              <a:spcBef>
-                <a:spcPts val="0"/>
-              </a:spcBef>
-              <a:spcAft>
-                <a:spcPts val="0"/>
-              </a:spcAft>
-              <a:buNone/>
-            </a:pPr>
-            <a:r>
-              <a:rPr lang="en-US" sz="800" i="1" dirty="0">
-                <a:solidFill>
-                  <a:schemeClr val="dk1"/>
-                </a:solidFill>
-                <a:latin typeface="Poppins"/>
-                <a:ea typeface="Poppins"/>
-                <a:cs typeface="Poppins"/>
-                <a:sym typeface="Poppins"/>
-              </a:rPr>
-              <a:t>This material is based upon work supported by the NSF National Center for Atmospheric Research, a major facility sponsored by the U.S. National Science Foundation and managed by the University Corporation for Atmospheric Research. Any opinions, findings and conclusions or recommendations expressed in this material do not necessarily reflect the views of NSF.</a:t>
-            </a:r>
-          </a:p>
-          <a:p>
-            <a:pPr marL="0" lvl="0" indent="0" algn="l" rtl="0">
-              <a:spcBef>
-                <a:spcPts val="0"/>
-              </a:spcBef>
-              <a:spcAft>
-                <a:spcPts val="0"/>
-              </a:spcAft>
-              <a:buNone/>
-            </a:pPr>
-            <a:endParaRPr lang="en-US" sz="800" i="1" dirty="0">
               <a:solidFill>
                 <a:schemeClr val="dk1"/>
               </a:solidFill>
@@ -5222,7 +5404,7 @@
 </file>
 
 <file path=ppt/theme/theme1.xml><?xml version="1.0" encoding="utf-8"?>
-<a:theme xmlns:a="http://schemas.openxmlformats.org/drawingml/2006/main" name="Office Theme">
+<a:theme xmlns:a="http://schemas.openxmlformats.org/drawingml/2006/main" name="NCAR Theme">
   <a:themeElements>
     <a:clrScheme name="NCAR_UCAR_Colors_2026">
       <a:dk1>

</xml_diff>

<commit_message>
remove stray hanging indent
</commit_message>
<xml_diff>
--- a/docs/presentations/common/branding/ncar/template.pptx
+++ b/docs/presentations/common/branding/ncar/template.pptx
@@ -1645,7 +1645,7 @@
         <p:txBody>
           <a:bodyPr/>
           <a:lstStyle>
-            <a:lvl1pPr marL="228600" indent="-228600">
+            <a:lvl1pPr marL="0" indent="0">
               <a:buClrTx/>
               <a:buFontTx/>
               <a:buNone/>
@@ -1670,10 +1670,6 @@
               <a:defRPr baseline="0"/>
             </a:lvl5pPr>
           </a:lstStyle>
-          <a:p>
-            <a:pPr lvl="0"/>
-            <a:endParaRPr lang="en-US" dirty="0"/>
-          </a:p>
           <a:p>
             <a:pPr lvl="0"/>
             <a:r>
@@ -4216,10 +4212,6 @@
             <a:normAutofit/>
           </a:bodyPr>
           <a:lstStyle/>
-          <a:p>
-            <a:pPr lvl="0"/>
-            <a:endParaRPr lang="en-US" dirty="0"/>
-          </a:p>
           <a:p>
             <a:pPr lvl="0"/>
             <a:r>

</xml_diff>

<commit_message>
make title box autofit
</commit_message>
<xml_diff>
--- a/docs/presentations/common/branding/ncar/template.pptx
+++ b/docs/presentations/common/branding/ncar/template.pptx
@@ -918,7 +918,9 @@
           <a:noFill/>
         </p:spPr>
         <p:txBody>
-          <a:bodyPr/>
+          <a:bodyPr>
+            <a:normAutofit/>
+          </a:bodyPr>
           <a:lstStyle>
             <a:lvl1pPr>
               <a:defRPr sz="2800" b="1" baseline="0"/>

</xml_diff>